<commit_message>
Update extrapolation PPT: Xu Fig.1 slide and layout fixes
Co-authored-by: Cursor <cursoragent@cursor.com>
</commit_message>
<xml_diff>
--- a/extrapolation-papers/외삽_50분_발표자료.pptx
+++ b/extrapolation-papers/외삽_50분_발표자료.pptx
@@ -38,6 +38,7 @@
     <p:sldId id="292" r:id="rId29"/>
     <p:sldId id="279" r:id="rId30"/>
     <p:sldId id="280" r:id="rId31"/>
+    <p:sldId id="294" r:id="rId45"/>
     <p:sldId id="293" r:id="rId32"/>
     <p:sldId id="281" r:id="rId33"/>
     <p:sldId id="282" r:id="rId34"/>
@@ -3754,7 +3755,7 @@
         <p:spPr>
           <a:xfrm>
             <a:off x="-1188720" y="2926080"/>
-            <a:ext cx="3474720" cy="3474720"/>
+            <a:ext cx="3474720" cy="2197420"/>
           </a:xfrm>
           <a:prstGeom prst="ellipse">
             <a:avLst/>
@@ -4946,8 +4947,8 @@
         </p:nvSpPr>
         <p:spPr>
           <a:xfrm>
-            <a:off x="365760" y="5623560"/>
-            <a:ext cx="8412480" cy="868680"/>
+            <a:off x="365760" y="4773168"/>
+            <a:ext cx="8412480" cy="256032"/>
           </a:xfrm>
           <a:prstGeom prst="roundRect">
             <a:avLst/>
@@ -6170,7 +6171,7 @@
         <p:spPr>
           <a:xfrm>
             <a:off x="-1097280" y="2926080"/>
-            <a:ext cx="3200400" cy="3200400"/>
+            <a:ext cx="3200400" cy="2197420"/>
           </a:xfrm>
           <a:prstGeom prst="ellipse">
             <a:avLst/>
@@ -6407,7 +6408,6 @@
           <a:lstStyle/>
           <a:p>
             <a:pPr algn="ctr"/>
-            <a:endParaRPr/>
           </a:p>
         </p:txBody>
       </p:sp>
@@ -6514,7 +6514,7 @@
         <p:spPr>
           <a:xfrm>
             <a:off x="5486400" y="1097280"/>
-            <a:ext cx="3291840" cy="4572000"/>
+            <a:ext cx="3291840" cy="4026220"/>
           </a:xfrm>
           <a:prstGeom prst="rect">
             <a:avLst/>
@@ -6611,7 +6611,7 @@
         </p:nvSpPr>
         <p:spPr>
           <a:xfrm>
-            <a:off x="457200" y="5989320"/>
+            <a:off x="457200" y="4773168"/>
             <a:ext cx="8229600" cy="320040"/>
           </a:xfrm>
           <a:prstGeom prst="rect">
@@ -12854,7 +12854,7 @@
         <p:spPr>
           <a:xfrm>
             <a:off x="-1097280" y="2926080"/>
-            <a:ext cx="3200400" cy="3200400"/>
+            <a:ext cx="3200400" cy="2197420"/>
           </a:xfrm>
           <a:prstGeom prst="ellipse">
             <a:avLst/>
@@ -13976,7 +13976,7 @@
         <p:spPr>
           <a:xfrm>
             <a:off x="0" y="0"/>
-            <a:ext cx="9144000" cy="50292"/>
+            <a:ext cx="9144000" cy="36000"/>
           </a:xfrm>
           <a:prstGeom prst="rect">
             <a:avLst/>
@@ -14007,7 +14007,6 @@
           <a:lstStyle/>
           <a:p>
             <a:pPr algn="ctr"/>
-            <a:endParaRPr/>
           </a:p>
         </p:txBody>
       </p:sp>
@@ -14019,29 +14018,28 @@
         </p:nvSpPr>
         <p:spPr>
           <a:xfrm>
-            <a:off x="457200" y="91440"/>
-            <a:ext cx="8229600" cy="201168"/>
-          </a:xfrm>
-          <a:prstGeom prst="rect">
-            <a:avLst/>
-          </a:prstGeom>
-          <a:noFill/>
-        </p:spPr>
-        <p:txBody>
-          <a:bodyPr wrap="square">
+            <a:off x="365760" y="91440"/>
+            <a:ext cx="8412480" cy="219456"/>
+          </a:xfrm>
+          <a:prstGeom prst="rect">
+            <a:avLst/>
+          </a:prstGeom>
+          <a:noFill/>
+        </p:spPr>
+        <p:txBody>
+          <a:bodyPr wrap="none">
             <a:spAutoFit/>
           </a:bodyPr>
           <a:lstStyle/>
           <a:p>
-            <a:pPr algn="l">
-              <a:defRPr sz="1400" b="1">
+            <a:r>
+              <a:rPr sz="1100" b="1">
                 <a:solidFill>
                   <a:srgbClr val="2E86AB"/>
                 </a:solidFill>
-              </a:defRPr>
-            </a:pPr>
-            <a:r>
-              <a:t>PART 3 · 실전 예시</a:t>
+                <a:latin typeface="맑은 고딕"/>
+              </a:rPr>
+              <a:t>PART 3  ·  Xu et al. (2021)</a:t>
             </a:r>
           </a:p>
         </p:txBody>
@@ -14054,51 +14052,50 @@
         </p:nvSpPr>
         <p:spPr>
           <a:xfrm>
-            <a:off x="457200" y="347472"/>
-            <a:ext cx="8229600" cy="594360"/>
-          </a:xfrm>
-          <a:prstGeom prst="rect">
-            <a:avLst/>
-          </a:prstGeom>
-          <a:noFill/>
-        </p:spPr>
-        <p:txBody>
-          <a:bodyPr wrap="square">
+            <a:off x="365760" y="292608"/>
+            <a:ext cx="8412480" cy="347472"/>
+          </a:xfrm>
+          <a:prstGeom prst="rect">
+            <a:avLst/>
+          </a:prstGeom>
+          <a:noFill/>
+        </p:spPr>
+        <p:txBody>
+          <a:bodyPr wrap="none">
             <a:spAutoFit/>
           </a:bodyPr>
           <a:lstStyle/>
           <a:p>
-            <a:pPr algn="l">
-              <a:defRPr sz="2600" b="1">
+            <a:r>
+              <a:rPr sz="2000" b="1">
                 <a:solidFill>
                   <a:srgbClr val="1A2B4B"/>
                 </a:solidFill>
-              </a:defRPr>
-            </a:pPr>
-            <a:r>
-              <a:t>활성화 함수별 외삽 거동</a:t>
+                <a:latin typeface="맑은 고딕"/>
+              </a:rPr>
+              <a:t>ReLU MLP는 왜 범위 밖에서 직선이 되는가</a:t>
             </a:r>
           </a:p>
         </p:txBody>
       </p:sp>
       <p:pic>
         <p:nvPicPr>
-          <p:cNvPr id="5" name="Picture 4" descr="image.png"/>
+          <p:cNvPr id="5" name="Picture 4" descr="16_xu_fig1_clean.png"/>
           <p:cNvPicPr>
             <a:picLocks noChangeAspect="1"/>
           </p:cNvPicPr>
           <p:nvPr/>
         </p:nvPicPr>
         <p:blipFill>
-          <a:blip r:embed="rId3"/>
+          <a:blip r:embed="rId6"/>
           <a:stretch>
             <a:fillRect/>
           </a:stretch>
         </p:blipFill>
         <p:spPr>
           <a:xfrm>
-            <a:off x="365760" y="1097280"/>
-            <a:ext cx="5029200" cy="2382253"/>
+            <a:off x="411480" y="713232"/>
+            <a:ext cx="8321040" cy="2716294"/>
           </a:xfrm>
           <a:prstGeom prst="rect">
             <a:avLst/>
@@ -14107,118 +14104,244 @@
       </p:pic>
       <p:sp>
         <p:nvSpPr>
-          <p:cNvPr id="6" name="TextBox 5"/>
+          <p:cNvPr id="6" name="Rounded Rectangle 5"/>
+          <p:cNvSpPr/>
+          <p:nvPr/>
+        </p:nvSpPr>
+        <p:spPr>
+          <a:xfrm>
+            <a:off x="365760" y="3794760"/>
+            <a:ext cx="2697480" cy="804672"/>
+          </a:xfrm>
+          <a:prstGeom prst="roundRect">
+            <a:avLst/>
+          </a:prstGeom>
+          <a:solidFill>
+            <a:srgbClr val="F4F7FA"/>
+          </a:solidFill>
+          <a:ln w="12700">
+            <a:solidFill>
+              <a:srgbClr val="E8F1F8"/>
+            </a:solidFill>
+          </a:ln>
+        </p:spPr>
+        <p:style>
+          <a:lnRef idx="1">
+            <a:schemeClr val="accent1"/>
+          </a:lnRef>
+          <a:fillRef idx="3">
+            <a:schemeClr val="accent1"/>
+          </a:fillRef>
+          <a:effectRef idx="2">
+            <a:schemeClr val="accent1"/>
+          </a:effectRef>
+          <a:fontRef idx="minor">
+            <a:schemeClr val="lt1"/>
+          </a:fontRef>
+        </p:style>
+        <p:txBody>
+          <a:bodyPr rtlCol="0" anchor="ctr" wrap="square" lIns="109728" tIns="91440"/>
+          <a:lstStyle/>
+          <a:p>
+            <a:pPr algn="ctr"/>
+            <a:r>
+              <a:rPr sz="1200" b="1">
+                <a:solidFill>
+                  <a:srgbClr val="2E86AB"/>
+                </a:solidFill>
+                <a:latin typeface="맑은 고딕"/>
+              </a:rPr>
+              <a:t>관측 (Fig.1)</a:t>
+            </a:r>
+          </a:p>
+          <a:p>
+            <a:pPr>
+              <a:spcBef>
+                <a:spcPts val="400"/>
+              </a:spcBef>
+            </a:pPr>
+            <a:r>
+              <a:rPr sz="1100" b="0">
+                <a:solidFill>
+                  <a:srgbClr val="1A2B4B"/>
+                </a:solidFill>
+                <a:latin typeface="맑은 고딕"/>
+              </a:rPr>
+              <a:t>파랑=훈련 안 · 검정=밖 → 밖에서는 평면/직선</a:t>
+            </a:r>
+          </a:p>
+        </p:txBody>
+      </p:sp>
+      <p:sp>
+        <p:nvSpPr>
+          <p:cNvPr id="7" name="Rounded Rectangle 6"/>
+          <p:cNvSpPr/>
+          <p:nvPr/>
+        </p:nvSpPr>
+        <p:spPr>
+          <a:xfrm>
+            <a:off x="3200400" y="3794760"/>
+            <a:ext cx="2697480" cy="804672"/>
+          </a:xfrm>
+          <a:prstGeom prst="roundRect">
+            <a:avLst/>
+          </a:prstGeom>
+          <a:solidFill>
+            <a:srgbClr val="F4F7FA"/>
+          </a:solidFill>
+          <a:ln w="12700">
+            <a:solidFill>
+              <a:srgbClr val="E8F1F8"/>
+            </a:solidFill>
+          </a:ln>
+        </p:spPr>
+        <p:style>
+          <a:lnRef idx="1">
+            <a:schemeClr val="accent1"/>
+          </a:lnRef>
+          <a:fillRef idx="3">
+            <a:schemeClr val="accent1"/>
+          </a:fillRef>
+          <a:effectRef idx="2">
+            <a:schemeClr val="accent1"/>
+          </a:effectRef>
+          <a:fontRef idx="minor">
+            <a:schemeClr val="lt1"/>
+          </a:fontRef>
+        </p:style>
+        <p:txBody>
+          <a:bodyPr rtlCol="0" anchor="ctr" wrap="square" lIns="109728" tIns="91440"/>
+          <a:lstStyle/>
+          <a:p>
+            <a:pPr algn="ctr"/>
+            <a:r>
+              <a:rPr sz="1200" b="1">
+                <a:solidFill>
+                  <a:srgbClr val="2E86AB"/>
+                </a:solidFill>
+                <a:latin typeface="맑은 고딕"/>
+              </a:rPr>
+              <a:t>Theorem 1</a:t>
+            </a:r>
+          </a:p>
+          <a:p>
+            <a:pPr>
+              <a:spcBef>
+                <a:spcPts val="400"/>
+              </a:spcBef>
+            </a:pPr>
+            <a:r>
+              <a:rPr sz="1100" b="0">
+                <a:solidFill>
+                  <a:srgbClr val="1A2B4B"/>
+                </a:solidFill>
+                <a:latin typeface="맑은 고딕"/>
+              </a:rPr>
+              <a:t>원점 방향 v로 O(1/t) affine 수렴 (beta_v)</a:t>
+            </a:r>
+          </a:p>
+        </p:txBody>
+      </p:sp>
+      <p:sp>
+        <p:nvSpPr>
+          <p:cNvPr id="8" name="Rounded Rectangle 7"/>
+          <p:cNvSpPr/>
+          <p:nvPr/>
+        </p:nvSpPr>
+        <p:spPr>
+          <a:xfrm>
+            <a:off x="6035040" y="3794760"/>
+            <a:ext cx="2697480" cy="804672"/>
+          </a:xfrm>
+          <a:prstGeom prst="roundRect">
+            <a:avLst/>
+          </a:prstGeom>
+          <a:solidFill>
+            <a:srgbClr val="F4F7FA"/>
+          </a:solidFill>
+          <a:ln w="12700">
+            <a:solidFill>
+              <a:srgbClr val="E8F1F8"/>
+            </a:solidFill>
+          </a:ln>
+        </p:spPr>
+        <p:style>
+          <a:lnRef idx="1">
+            <a:schemeClr val="accent1"/>
+          </a:lnRef>
+          <a:fillRef idx="3">
+            <a:schemeClr val="accent1"/>
+          </a:fillRef>
+          <a:effectRef idx="2">
+            <a:schemeClr val="accent1"/>
+          </a:effectRef>
+          <a:fontRef idx="minor">
+            <a:schemeClr val="lt1"/>
+          </a:fontRef>
+        </p:style>
+        <p:txBody>
+          <a:bodyPr rtlCol="0" anchor="ctr" wrap="square" lIns="109728" tIns="91440"/>
+          <a:lstStyle/>
+          <a:p>
+            <a:pPr algn="ctr"/>
+            <a:r>
+              <a:rPr sz="1200" b="1">
+                <a:solidFill>
+                  <a:srgbClr val="2E86AB"/>
+                </a:solidFill>
+                <a:latin typeface="맑은 고딕"/>
+              </a:rPr>
+              <a:t>실험 확인</a:t>
+            </a:r>
+          </a:p>
+          <a:p>
+            <a:pPr>
+              <a:spcBef>
+                <a:spcPts val="400"/>
+              </a:spcBef>
+            </a:pPr>
+            <a:r>
+              <a:rPr sz="1100" b="0">
+                <a:solidFill>
+                  <a:srgbClr val="1A2B4B"/>
+                </a:solidFill>
+                <a:latin typeface="맑은 고딕"/>
+              </a:rPr>
+              <a:t>Appendix C.2 · 범위 밖 선형적합 R² &gt; 0.99</a:t>
+            </a:r>
+          </a:p>
+        </p:txBody>
+      </p:sp>
+      <p:sp>
+        <p:nvSpPr>
+          <p:cNvPr id="9" name="TextBox 8"/>
           <p:cNvSpPr txBox="1"/>
           <p:nvPr/>
         </p:nvSpPr>
         <p:spPr>
           <a:xfrm>
-            <a:off x="5486400" y="1097280"/>
-            <a:ext cx="3291840" cy="4572000"/>
-          </a:xfrm>
-          <a:prstGeom prst="rect">
-            <a:avLst/>
-          </a:prstGeom>
-          <a:noFill/>
-        </p:spPr>
-        <p:txBody>
-          <a:bodyPr wrap="square">
+            <a:off x="365760" y="4773168"/>
+            <a:ext cx="8412480" cy="256032"/>
+          </a:xfrm>
+          <a:prstGeom prst="rect">
+            <a:avLst/>
+          </a:prstGeom>
+          <a:noFill/>
+        </p:spPr>
+        <p:txBody>
+          <a:bodyPr wrap="none">
             <a:spAutoFit/>
           </a:bodyPr>
           <a:lstStyle/>
           <a:p>
-            <a:pPr>
-              <a:spcAft>
-                <a:spcPts val="600"/>
-              </a:spcAft>
-              <a:defRPr sz="1100">
-                <a:solidFill>
-                  <a:srgbClr val="1A2B4B"/>
-                </a:solidFill>
-              </a:defRPr>
-            </a:pPr>
-            <a:r>
-              <a:t>ReLU: 마지막 선형 구간 연장</a:t>
-            </a:r>
-          </a:p>
-          <a:p>
-            <a:pPr>
-              <a:spcAft>
-                <a:spcPts val="600"/>
-              </a:spcAft>
-              <a:defRPr sz="1100">
-                <a:solidFill>
-                  <a:srgbClr val="1A2B4B"/>
-                </a:solidFill>
-              </a:defRPr>
-            </a:pPr>
-            <a:r>
-              <a:t>Tanh: 포화 -&gt; 회귀에 치명적</a:t>
-            </a:r>
-          </a:p>
-          <a:p>
-            <a:pPr>
-              <a:spcAft>
-                <a:spcPts val="600"/>
-              </a:spcAft>
-              <a:defRPr sz="1100">
-                <a:solidFill>
-                  <a:srgbClr val="1A2B4B"/>
-                </a:solidFill>
-              </a:defRPr>
-            </a:pPr>
-            <a:r>
-              <a:t>Sin: 주기 반복 -&gt; 물리 해석 주의</a:t>
-            </a:r>
-          </a:p>
-          <a:p>
-            <a:pPr>
-              <a:spcAft>
-                <a:spcPts val="600"/>
-              </a:spcAft>
-              <a:defRPr sz="1100">
-                <a:solidFill>
-                  <a:srgbClr val="1A2B4B"/>
-                </a:solidFill>
-              </a:defRPr>
-            </a:pPr>
-            <a:r>
-              <a:t>교훈: 아키텍처 = 외삽 가정</a:t>
-            </a:r>
-          </a:p>
-        </p:txBody>
-      </p:sp>
-      <p:sp>
-        <p:nvSpPr>
-          <p:cNvPr id="7" name="TextBox 6"/>
-          <p:cNvSpPr txBox="1"/>
-          <p:nvPr/>
-        </p:nvSpPr>
-        <p:spPr>
-          <a:xfrm>
-            <a:off x="457200" y="5989320"/>
-            <a:ext cx="8229600" cy="320040"/>
-          </a:xfrm>
-          <a:prstGeom prst="rect">
-            <a:avLst/>
-          </a:prstGeom>
-          <a:noFill/>
-        </p:spPr>
-        <p:txBody>
-          <a:bodyPr wrap="square">
-            <a:spAutoFit/>
-          </a:bodyPr>
-          <a:lstStyle/>
-          <a:p>
-            <a:pPr algn="l">
-              <a:defRPr sz="900" b="0">
-                <a:solidFill>
-                  <a:srgbClr val="555555"/>
-                </a:solidFill>
-              </a:defRPr>
-            </a:pPr>
-            <a:r>
-              <a:t>Xu et al. (2021)</a:t>
+            <a:r>
+              <a:rPr sz="900" b="0">
+                <a:solidFill>
+                  <a:srgbClr val="5A5A5A"/>
+                </a:solidFill>
+                <a:latin typeface="맑은 고딕"/>
+              </a:rPr>
+              <a:t>Xu et al., ICLR 2021  ·  How Neural Networks Extrapolate  ·  arxiv:2009.11848  ·  Figure 1 / Theorem 1</a:t>
             </a:r>
           </a:p>
         </p:txBody>
@@ -14258,1548 +14381,23 @@
       </p:grpSpPr>
       <p:sp>
         <p:nvSpPr>
-          <p:cNvPr id="2" name="Shape 0"/>
+          <p:cNvPr id="2" name="Rectangle 1"/>
           <p:cNvSpPr/>
           <p:nvPr/>
         </p:nvSpPr>
         <p:spPr>
           <a:xfrm>
             <a:off x="0" y="0"/>
-            <a:ext cx="9144000" cy="50292"/>
+            <a:ext cx="9144000" cy="36000"/>
           </a:xfrm>
           <a:prstGeom prst="rect">
             <a:avLst/>
           </a:prstGeom>
           <a:solidFill>
-            <a:srgbClr val="01696F"/>
-          </a:solidFill>
-          <a:ln w="12700">
-            <a:solidFill>
-              <a:srgbClr val="01696F"/>
-            </a:solidFill>
-            <a:prstDash val="solid"/>
-          </a:ln>
-        </p:spPr>
-        <p:txBody>
-          <a:bodyPr/>
-          <a:lstStyle/>
-          <a:p>
-            <a:endParaRPr/>
-          </a:p>
-        </p:txBody>
-      </p:sp>
-      <p:sp>
-        <p:nvSpPr>
-          <p:cNvPr id="3" name="Text 1"/>
-          <p:cNvSpPr/>
-          <p:nvPr/>
-        </p:nvSpPr>
-        <p:spPr>
-          <a:xfrm>
-            <a:off x="457200" y="91440"/>
-            <a:ext cx="8229600" cy="201168"/>
-          </a:xfrm>
-          <a:prstGeom prst="rect">
-            <a:avLst/>
-          </a:prstGeom>
-          <a:noFill/>
-          <a:ln/>
-        </p:spPr>
-        <p:txBody>
-          <a:bodyPr wrap="square" rtlCol="0" anchor="ctr"/>
-          <a:lstStyle/>
-          <a:p>
-            <a:pPr marL="0" indent="0">
-              <a:buNone/>
-            </a:pPr>
-            <a:r>
-              <a:rPr lang="en-US" sz="750" b="1" kern="0" spc="200" dirty="0">
-                <a:solidFill>
-                  <a:srgbClr val="01696F"/>
-                </a:solidFill>
-                <a:latin typeface="Calibri" pitchFamily="34" charset="0"/>
-                <a:ea typeface="Calibri" pitchFamily="34" charset="-122"/>
-                <a:cs typeface="Calibri" pitchFamily="34" charset="-120"/>
-              </a:rPr>
-              <a:t>PART 3 · 신경망 외삽</a:t>
-            </a:r>
-            <a:endParaRPr lang="en-US" sz="750" dirty="0"/>
-          </a:p>
-        </p:txBody>
-      </p:sp>
-      <p:sp>
-        <p:nvSpPr>
-          <p:cNvPr id="4" name="Text 2"/>
-          <p:cNvSpPr/>
-          <p:nvPr/>
-        </p:nvSpPr>
-        <p:spPr>
-          <a:xfrm>
-            <a:off x="457200" y="347472"/>
-            <a:ext cx="8229600" cy="594360"/>
-          </a:xfrm>
-          <a:prstGeom prst="rect">
-            <a:avLst/>
-          </a:prstGeom>
-          <a:noFill/>
-          <a:ln/>
-        </p:spPr>
-        <p:txBody>
-          <a:bodyPr wrap="square" rtlCol="0" anchor="ctr"/>
-          <a:lstStyle/>
-          <a:p>
-            <a:pPr marL="0" indent="0" algn="l">
-              <a:buNone/>
-            </a:pPr>
-            <a:r>
-              <a:rPr lang="en-US" sz="2500" b="1" dirty="0">
-                <a:solidFill>
-                  <a:srgbClr val="0C4E54"/>
-                </a:solidFill>
-                <a:latin typeface="Trebuchet MS" pitchFamily="34" charset="0"/>
-                <a:ea typeface="Trebuchet MS" pitchFamily="34" charset="-122"/>
-                <a:cs typeface="Trebuchet MS" pitchFamily="34" charset="-120"/>
-              </a:rPr>
-              <a:t>신경망은 왜 외삽에 실패하는가</a:t>
-            </a:r>
-            <a:endParaRPr lang="en-US" sz="2500" dirty="0"/>
-          </a:p>
-        </p:txBody>
-      </p:sp>
-      <p:sp>
-        <p:nvSpPr>
-          <p:cNvPr id="5" name="Shape 3"/>
-          <p:cNvSpPr/>
-          <p:nvPr/>
-        </p:nvSpPr>
-        <p:spPr>
-          <a:xfrm>
-            <a:off x="457200" y="987552"/>
-            <a:ext cx="8229600" cy="14630"/>
-          </a:xfrm>
-          <a:prstGeom prst="rect">
-            <a:avLst/>
-          </a:prstGeom>
-          <a:solidFill>
-            <a:srgbClr val="D4D1CA"/>
-          </a:solidFill>
-          <a:ln w="12700">
-            <a:solidFill>
-              <a:srgbClr val="D4D1CA"/>
-            </a:solidFill>
-            <a:prstDash val="solid"/>
-          </a:ln>
-        </p:spPr>
-        <p:txBody>
-          <a:bodyPr/>
-          <a:lstStyle/>
-          <a:p>
-            <a:endParaRPr/>
-          </a:p>
-        </p:txBody>
-      </p:sp>
-      <p:sp>
-        <p:nvSpPr>
-          <p:cNvPr id="6" name="Text 4"/>
-          <p:cNvSpPr/>
-          <p:nvPr/>
-        </p:nvSpPr>
-        <p:spPr>
-          <a:xfrm>
-            <a:off x="457200" y="1078992"/>
-            <a:ext cx="8229600" cy="219456"/>
-          </a:xfrm>
-          <a:prstGeom prst="rect">
-            <a:avLst/>
-          </a:prstGeom>
-          <a:noFill/>
-          <a:ln/>
-        </p:spPr>
-        <p:txBody>
-          <a:bodyPr wrap="square" lIns="0" tIns="0" rIns="0" bIns="0" rtlCol="0" anchor="ctr"/>
-          <a:lstStyle/>
-          <a:p>
-            <a:pPr marL="0" indent="0">
-              <a:buNone/>
-            </a:pPr>
-            <a:r>
-              <a:rPr lang="en-US" sz="900" b="1" i="1" dirty="0">
-                <a:solidFill>
-                  <a:srgbClr val="01696F"/>
-                </a:solidFill>
-                <a:latin typeface="Calibri" pitchFamily="34" charset="0"/>
-                <a:ea typeface="Calibri" pitchFamily="34" charset="-122"/>
-                <a:cs typeface="Calibri" pitchFamily="34" charset="-120"/>
-              </a:rPr>
-              <a:t>Xu et al. (2021) "How Neural Networks Extrapolate: From Feedforward to GNN"</a:t>
-            </a:r>
-            <a:endParaRPr lang="en-US" sz="900" dirty="0"/>
-          </a:p>
-        </p:txBody>
-      </p:sp>
-      <p:sp>
-        <p:nvSpPr>
-          <p:cNvPr id="7" name="Shape 5"/>
-          <p:cNvSpPr/>
-          <p:nvPr/>
-        </p:nvSpPr>
-        <p:spPr>
-          <a:xfrm>
-            <a:off x="457200" y="1389888"/>
-            <a:ext cx="1920240" cy="3429000"/>
-          </a:xfrm>
-          <a:prstGeom prst="rect">
-            <a:avLst/>
-          </a:prstGeom>
-          <a:solidFill>
-            <a:srgbClr val="FFFFFF"/>
-          </a:solidFill>
-          <a:ln w="12700">
-            <a:solidFill>
-              <a:srgbClr val="D4D1CA"/>
-            </a:solidFill>
-            <a:prstDash val="solid"/>
-          </a:ln>
-          <a:effectLst>
-            <a:outerShdw blurRad="63500" dist="25400" dir="8700000" algn="bl" rotWithShape="0">
-              <a:srgbClr val="28251D">
-                <a:alpha val="7000"/>
-              </a:srgbClr>
-            </a:outerShdw>
-          </a:effectLst>
-        </p:spPr>
-        <p:txBody>
-          <a:bodyPr/>
-          <a:lstStyle/>
-          <a:p>
-            <a:endParaRPr/>
-          </a:p>
-        </p:txBody>
-      </p:sp>
-      <p:sp>
-        <p:nvSpPr>
-          <p:cNvPr id="8" name="Shape 6"/>
-          <p:cNvSpPr/>
-          <p:nvPr/>
-        </p:nvSpPr>
-        <p:spPr>
-          <a:xfrm>
-            <a:off x="457200" y="1389888"/>
-            <a:ext cx="1920240" cy="73152"/>
-          </a:xfrm>
-          <a:prstGeom prst="rect">
-            <a:avLst/>
-          </a:prstGeom>
-          <a:solidFill>
-            <a:srgbClr val="01696F"/>
-          </a:solidFill>
-          <a:ln w="12700">
-            <a:solidFill>
-              <a:srgbClr val="01696F"/>
-            </a:solidFill>
-            <a:prstDash val="solid"/>
-          </a:ln>
-        </p:spPr>
-        <p:txBody>
-          <a:bodyPr/>
-          <a:lstStyle/>
-          <a:p>
-            <a:endParaRPr/>
-          </a:p>
-        </p:txBody>
-      </p:sp>
-      <p:sp>
-        <p:nvSpPr>
-          <p:cNvPr id="9" name="Text 7"/>
-          <p:cNvSpPr/>
-          <p:nvPr/>
-        </p:nvSpPr>
-        <p:spPr>
-          <a:xfrm>
-            <a:off x="566928" y="1536192"/>
-            <a:ext cx="1700784" cy="384048"/>
-          </a:xfrm>
-          <a:prstGeom prst="rect">
-            <a:avLst/>
-          </a:prstGeom>
-          <a:noFill/>
-          <a:ln/>
-        </p:spPr>
-        <p:txBody>
-          <a:bodyPr wrap="square" lIns="0" tIns="0" rIns="0" bIns="0" rtlCol="0" anchor="ctr"/>
-          <a:lstStyle/>
-          <a:p>
-            <a:pPr marL="0" indent="0">
-              <a:buNone/>
-            </a:pPr>
-            <a:r>
-              <a:rPr lang="en-US" sz="1250" b="1" dirty="0">
-                <a:solidFill>
-                  <a:srgbClr val="28251D"/>
-                </a:solidFill>
-                <a:latin typeface="Trebuchet MS" pitchFamily="34" charset="0"/>
-                <a:ea typeface="Trebuchet MS" pitchFamily="34" charset="-122"/>
-                <a:cs typeface="Trebuchet MS" pitchFamily="34" charset="-120"/>
-              </a:rPr>
-              <a:t>ReLU</a:t>
-            </a:r>
-            <a:endParaRPr lang="en-US" sz="1250" dirty="0"/>
-          </a:p>
-        </p:txBody>
-      </p:sp>
-      <p:sp>
-        <p:nvSpPr>
-          <p:cNvPr id="10" name="Text 8"/>
-          <p:cNvSpPr/>
-          <p:nvPr/>
-        </p:nvSpPr>
-        <p:spPr>
-          <a:xfrm>
-            <a:off x="566928" y="2011680"/>
-            <a:ext cx="1700784" cy="201168"/>
-          </a:xfrm>
-          <a:prstGeom prst="rect">
-            <a:avLst/>
-          </a:prstGeom>
-          <a:noFill/>
-          <a:ln/>
-        </p:spPr>
-        <p:txBody>
-          <a:bodyPr wrap="square" lIns="0" tIns="0" rIns="0" bIns="0" rtlCol="0" anchor="ctr"/>
-          <a:lstStyle/>
-          <a:p>
-            <a:pPr marL="0" indent="0">
-              <a:buNone/>
-            </a:pPr>
-            <a:r>
-              <a:rPr lang="en-US" sz="800" b="1" dirty="0">
-                <a:solidFill>
-                  <a:srgbClr val="01696F"/>
-                </a:solidFill>
-                <a:latin typeface="Calibri" pitchFamily="34" charset="0"/>
-                <a:ea typeface="Calibri" pitchFamily="34" charset="-122"/>
-                <a:cs typeface="Calibri" pitchFamily="34" charset="-120"/>
-              </a:rPr>
-              <a:t>범위 밖 거동</a:t>
-            </a:r>
-            <a:endParaRPr lang="en-US" sz="800" dirty="0"/>
-          </a:p>
-        </p:txBody>
-      </p:sp>
-      <p:sp>
-        <p:nvSpPr>
-          <p:cNvPr id="11" name="Text 9"/>
-          <p:cNvSpPr/>
-          <p:nvPr/>
-        </p:nvSpPr>
-        <p:spPr>
-          <a:xfrm>
-            <a:off x="566928" y="2231136"/>
-            <a:ext cx="1700784" cy="640080"/>
-          </a:xfrm>
-          <a:prstGeom prst="rect">
-            <a:avLst/>
-          </a:prstGeom>
-          <a:noFill/>
-          <a:ln/>
-        </p:spPr>
-        <p:txBody>
-          <a:bodyPr wrap="square" lIns="0" tIns="0" rIns="0" bIns="0" rtlCol="0" anchor="ctr"/>
-          <a:lstStyle/>
-          <a:p>
-            <a:pPr marL="0" indent="0">
-              <a:buNone/>
-            </a:pPr>
-            <a:r>
-              <a:rPr lang="en-US" sz="1100" dirty="0">
-                <a:solidFill>
-                  <a:srgbClr val="28251D"/>
-                </a:solidFill>
-                <a:latin typeface="Calibri" pitchFamily="34" charset="0"/>
-                <a:ea typeface="Calibri" pitchFamily="34" charset="-122"/>
-                <a:cs typeface="Calibri" pitchFamily="34" charset="-120"/>
-              </a:rPr>
-              <a:t>마지막 활성 구간이</a:t>
-            </a:r>
-            <a:endParaRPr lang="en-US" sz="1100" dirty="0"/>
-          </a:p>
-          <a:p>
-            <a:pPr marL="0" indent="0">
-              <a:buNone/>
-            </a:pPr>
-            <a:r>
-              <a:rPr lang="en-US" sz="1100" dirty="0">
-                <a:solidFill>
-                  <a:srgbClr val="28251D"/>
-                </a:solidFill>
-                <a:latin typeface="Calibri" pitchFamily="34" charset="0"/>
-                <a:ea typeface="Calibri" pitchFamily="34" charset="-122"/>
-                <a:cs typeface="Calibri" pitchFamily="34" charset="-120"/>
-              </a:rPr>
-              <a:t>선형으로 연장</a:t>
-            </a:r>
-            <a:endParaRPr lang="en-US" sz="1100" dirty="0"/>
-          </a:p>
-        </p:txBody>
-      </p:sp>
-      <p:sp>
-        <p:nvSpPr>
-          <p:cNvPr id="12" name="Text 10"/>
-          <p:cNvSpPr/>
-          <p:nvPr/>
-        </p:nvSpPr>
-        <p:spPr>
-          <a:xfrm>
-            <a:off x="566928" y="2971800"/>
-            <a:ext cx="1700784" cy="201168"/>
-          </a:xfrm>
-          <a:prstGeom prst="rect">
-            <a:avLst/>
-          </a:prstGeom>
-          <a:noFill/>
-          <a:ln/>
-        </p:spPr>
-        <p:txBody>
-          <a:bodyPr wrap="square" lIns="0" tIns="0" rIns="0" bIns="0" rtlCol="0" anchor="ctr"/>
-          <a:lstStyle/>
-          <a:p>
-            <a:pPr marL="0" indent="0">
-              <a:buNone/>
-            </a:pPr>
-            <a:r>
-              <a:rPr lang="en-US" sz="800" b="1" dirty="0">
-                <a:solidFill>
-                  <a:srgbClr val="7A7974"/>
-                </a:solidFill>
-                <a:latin typeface="Calibri" pitchFamily="34" charset="0"/>
-                <a:ea typeface="Calibri" pitchFamily="34" charset="-122"/>
-                <a:cs typeface="Calibri" pitchFamily="34" charset="-120"/>
-              </a:rPr>
-              <a:t>함의</a:t>
-            </a:r>
-            <a:endParaRPr lang="en-US" sz="800" dirty="0"/>
-          </a:p>
-        </p:txBody>
-      </p:sp>
-      <p:sp>
-        <p:nvSpPr>
-          <p:cNvPr id="13" name="Text 11"/>
-          <p:cNvSpPr/>
-          <p:nvPr/>
-        </p:nvSpPr>
-        <p:spPr>
-          <a:xfrm>
-            <a:off x="566928" y="3191256"/>
-            <a:ext cx="1700784" cy="594360"/>
-          </a:xfrm>
-          <a:prstGeom prst="rect">
-            <a:avLst/>
-          </a:prstGeom>
-          <a:noFill/>
-          <a:ln/>
-        </p:spPr>
-        <p:txBody>
-          <a:bodyPr wrap="square" lIns="0" tIns="0" rIns="0" bIns="0" rtlCol="0" anchor="ctr"/>
-          <a:lstStyle/>
-          <a:p>
-            <a:pPr marL="0" indent="0">
-              <a:buNone/>
-            </a:pPr>
-            <a:r>
-              <a:rPr lang="en-US" sz="1100" i="1" dirty="0">
-                <a:solidFill>
-                  <a:srgbClr val="7A7974"/>
-                </a:solidFill>
-                <a:latin typeface="Calibri" pitchFamily="34" charset="0"/>
-                <a:ea typeface="Calibri" pitchFamily="34" charset="-122"/>
-                <a:cs typeface="Calibri" pitchFamily="34" charset="-120"/>
-              </a:rPr>
-              <a:t>방향은 맞지만</a:t>
-            </a:r>
-            <a:endParaRPr lang="en-US" sz="1100" dirty="0"/>
-          </a:p>
-          <a:p>
-            <a:pPr marL="0" indent="0">
-              <a:buNone/>
-            </a:pPr>
-            <a:r>
-              <a:rPr lang="en-US" sz="1100" i="1" dirty="0">
-                <a:solidFill>
-                  <a:srgbClr val="7A7974"/>
-                </a:solidFill>
-                <a:latin typeface="Calibri" pitchFamily="34" charset="0"/>
-                <a:ea typeface="Calibri" pitchFamily="34" charset="-122"/>
-                <a:cs typeface="Calibri" pitchFamily="34" charset="-120"/>
-              </a:rPr>
-              <a:t>곡률 완전히 없음</a:t>
-            </a:r>
-            <a:endParaRPr lang="en-US" sz="1100" dirty="0"/>
-          </a:p>
-        </p:txBody>
-      </p:sp>
-      <p:sp>
-        <p:nvSpPr>
-          <p:cNvPr id="14" name="Shape 12"/>
-          <p:cNvSpPr/>
-          <p:nvPr/>
-        </p:nvSpPr>
-        <p:spPr>
-          <a:xfrm>
-            <a:off x="2542032" y="1389888"/>
-            <a:ext cx="1920240" cy="3429000"/>
-          </a:xfrm>
-          <a:prstGeom prst="rect">
-            <a:avLst/>
-          </a:prstGeom>
-          <a:solidFill>
-            <a:srgbClr val="FFFFFF"/>
-          </a:solidFill>
-          <a:ln w="12700">
-            <a:solidFill>
-              <a:srgbClr val="D4D1CA"/>
-            </a:solidFill>
-            <a:prstDash val="solid"/>
-          </a:ln>
-          <a:effectLst>
-            <a:outerShdw blurRad="63500" dist="25400" dir="8700000" algn="bl" rotWithShape="0">
-              <a:srgbClr val="28251D">
-                <a:alpha val="7000"/>
-              </a:srgbClr>
-            </a:outerShdw>
-          </a:effectLst>
-        </p:spPr>
-        <p:txBody>
-          <a:bodyPr/>
-          <a:lstStyle/>
-          <a:p>
-            <a:endParaRPr/>
-          </a:p>
-        </p:txBody>
-      </p:sp>
-      <p:sp>
-        <p:nvSpPr>
-          <p:cNvPr id="15" name="Shape 13"/>
-          <p:cNvSpPr/>
-          <p:nvPr/>
-        </p:nvSpPr>
-        <p:spPr>
-          <a:xfrm>
-            <a:off x="2542032" y="1389888"/>
-            <a:ext cx="1920240" cy="73152"/>
-          </a:xfrm>
-          <a:prstGeom prst="rect">
-            <a:avLst/>
-          </a:prstGeom>
-          <a:solidFill>
-            <a:srgbClr val="A84B2F"/>
-          </a:solidFill>
-          <a:ln w="12700">
-            <a:solidFill>
-              <a:srgbClr val="A84B2F"/>
-            </a:solidFill>
-            <a:prstDash val="solid"/>
-          </a:ln>
-        </p:spPr>
-        <p:txBody>
-          <a:bodyPr/>
-          <a:lstStyle/>
-          <a:p>
-            <a:endParaRPr/>
-          </a:p>
-        </p:txBody>
-      </p:sp>
-      <p:sp>
-        <p:nvSpPr>
-          <p:cNvPr id="16" name="Text 14"/>
-          <p:cNvSpPr/>
-          <p:nvPr/>
-        </p:nvSpPr>
-        <p:spPr>
-          <a:xfrm>
-            <a:off x="2651760" y="1536192"/>
-            <a:ext cx="1700784" cy="384048"/>
-          </a:xfrm>
-          <a:prstGeom prst="rect">
-            <a:avLst/>
-          </a:prstGeom>
-          <a:noFill/>
-          <a:ln/>
-        </p:spPr>
-        <p:txBody>
-          <a:bodyPr wrap="square" lIns="0" tIns="0" rIns="0" bIns="0" rtlCol="0" anchor="ctr"/>
-          <a:lstStyle/>
-          <a:p>
-            <a:pPr marL="0" indent="0">
-              <a:buNone/>
-            </a:pPr>
-            <a:r>
-              <a:rPr lang="en-US" sz="1250" b="1" dirty="0">
-                <a:solidFill>
-                  <a:srgbClr val="28251D"/>
-                </a:solidFill>
-                <a:latin typeface="Trebuchet MS" pitchFamily="34" charset="0"/>
-                <a:ea typeface="Trebuchet MS" pitchFamily="34" charset="-122"/>
-                <a:cs typeface="Trebuchet MS" pitchFamily="34" charset="-120"/>
-              </a:rPr>
-              <a:t>Tanh / Sigmoid</a:t>
-            </a:r>
-            <a:endParaRPr lang="en-US" sz="1250" dirty="0"/>
-          </a:p>
-        </p:txBody>
-      </p:sp>
-      <p:sp>
-        <p:nvSpPr>
-          <p:cNvPr id="17" name="Text 15"/>
-          <p:cNvSpPr/>
-          <p:nvPr/>
-        </p:nvSpPr>
-        <p:spPr>
-          <a:xfrm>
-            <a:off x="2651760" y="2011680"/>
-            <a:ext cx="1700784" cy="201168"/>
-          </a:xfrm>
-          <a:prstGeom prst="rect">
-            <a:avLst/>
-          </a:prstGeom>
-          <a:noFill/>
-          <a:ln/>
-        </p:spPr>
-        <p:txBody>
-          <a:bodyPr wrap="square" lIns="0" tIns="0" rIns="0" bIns="0" rtlCol="0" anchor="ctr"/>
-          <a:lstStyle/>
-          <a:p>
-            <a:pPr marL="0" indent="0">
-              <a:buNone/>
-            </a:pPr>
-            <a:r>
-              <a:rPr lang="en-US" sz="800" b="1" dirty="0">
-                <a:solidFill>
-                  <a:srgbClr val="A84B2F"/>
-                </a:solidFill>
-                <a:latin typeface="Calibri" pitchFamily="34" charset="0"/>
-                <a:ea typeface="Calibri" pitchFamily="34" charset="-122"/>
-                <a:cs typeface="Calibri" pitchFamily="34" charset="-120"/>
-              </a:rPr>
-              <a:t>범위 밖 거동</a:t>
-            </a:r>
-            <a:endParaRPr lang="en-US" sz="800" dirty="0"/>
-          </a:p>
-        </p:txBody>
-      </p:sp>
-      <p:sp>
-        <p:nvSpPr>
-          <p:cNvPr id="18" name="Text 16"/>
-          <p:cNvSpPr/>
-          <p:nvPr/>
-        </p:nvSpPr>
-        <p:spPr>
-          <a:xfrm>
-            <a:off x="2651760" y="2231136"/>
-            <a:ext cx="1700784" cy="640080"/>
-          </a:xfrm>
-          <a:prstGeom prst="rect">
-            <a:avLst/>
-          </a:prstGeom>
-          <a:noFill/>
-          <a:ln/>
-        </p:spPr>
-        <p:txBody>
-          <a:bodyPr wrap="square" lIns="0" tIns="0" rIns="0" bIns="0" rtlCol="0" anchor="ctr"/>
-          <a:lstStyle/>
-          <a:p>
-            <a:pPr marL="0" indent="0">
-              <a:buNone/>
-            </a:pPr>
-            <a:r>
-              <a:rPr lang="en-US" sz="1100" dirty="0">
-                <a:solidFill>
-                  <a:srgbClr val="28251D"/>
-                </a:solidFill>
-                <a:latin typeface="Calibri" pitchFamily="34" charset="0"/>
-                <a:ea typeface="Calibri" pitchFamily="34" charset="-122"/>
-                <a:cs typeface="Calibri" pitchFamily="34" charset="-120"/>
-              </a:rPr>
-              <a:t>포화(saturation)</a:t>
-            </a:r>
-            <a:endParaRPr lang="en-US" sz="1100" dirty="0"/>
-          </a:p>
-          <a:p>
-            <a:pPr marL="0" indent="0">
-              <a:buNone/>
-            </a:pPr>
-            <a:r>
-              <a:rPr lang="en-US" sz="1100" dirty="0">
-                <a:solidFill>
-                  <a:srgbClr val="28251D"/>
-                </a:solidFill>
-                <a:latin typeface="Calibri" pitchFamily="34" charset="0"/>
-                <a:ea typeface="Calibri" pitchFamily="34" charset="-122"/>
-                <a:cs typeface="Calibri" pitchFamily="34" charset="-120"/>
-              </a:rPr>
-              <a:t>→ 상수로 수렴</a:t>
-            </a:r>
-            <a:endParaRPr lang="en-US" sz="1100" dirty="0"/>
-          </a:p>
-        </p:txBody>
-      </p:sp>
-      <p:sp>
-        <p:nvSpPr>
-          <p:cNvPr id="19" name="Text 17"/>
-          <p:cNvSpPr/>
-          <p:nvPr/>
-        </p:nvSpPr>
-        <p:spPr>
-          <a:xfrm>
-            <a:off x="2651760" y="2971800"/>
-            <a:ext cx="1700784" cy="201168"/>
-          </a:xfrm>
-          <a:prstGeom prst="rect">
-            <a:avLst/>
-          </a:prstGeom>
-          <a:noFill/>
-          <a:ln/>
-        </p:spPr>
-        <p:txBody>
-          <a:bodyPr wrap="square" lIns="0" tIns="0" rIns="0" bIns="0" rtlCol="0" anchor="ctr"/>
-          <a:lstStyle/>
-          <a:p>
-            <a:pPr marL="0" indent="0">
-              <a:buNone/>
-            </a:pPr>
-            <a:r>
-              <a:rPr lang="en-US" sz="800" b="1" dirty="0">
-                <a:solidFill>
-                  <a:srgbClr val="7A7974"/>
-                </a:solidFill>
-                <a:latin typeface="Calibri" pitchFamily="34" charset="0"/>
-                <a:ea typeface="Calibri" pitchFamily="34" charset="-122"/>
-                <a:cs typeface="Calibri" pitchFamily="34" charset="-120"/>
-              </a:rPr>
-              <a:t>함의</a:t>
-            </a:r>
-            <a:endParaRPr lang="en-US" sz="800" dirty="0"/>
-          </a:p>
-        </p:txBody>
-      </p:sp>
-      <p:sp>
-        <p:nvSpPr>
-          <p:cNvPr id="20" name="Text 18"/>
-          <p:cNvSpPr/>
-          <p:nvPr/>
-        </p:nvSpPr>
-        <p:spPr>
-          <a:xfrm>
-            <a:off x="2651760" y="3191256"/>
-            <a:ext cx="1700784" cy="594360"/>
-          </a:xfrm>
-          <a:prstGeom prst="rect">
-            <a:avLst/>
-          </a:prstGeom>
-          <a:noFill/>
-          <a:ln/>
-        </p:spPr>
-        <p:txBody>
-          <a:bodyPr wrap="square" lIns="0" tIns="0" rIns="0" bIns="0" rtlCol="0" anchor="ctr"/>
-          <a:lstStyle/>
-          <a:p>
-            <a:pPr marL="0" indent="0">
-              <a:buNone/>
-            </a:pPr>
-            <a:r>
-              <a:rPr lang="en-US" sz="1100" i="1" dirty="0">
-                <a:solidFill>
-                  <a:srgbClr val="7A7974"/>
-                </a:solidFill>
-                <a:latin typeface="Calibri" pitchFamily="34" charset="0"/>
-                <a:ea typeface="Calibri" pitchFamily="34" charset="-122"/>
-                <a:cs typeface="Calibri" pitchFamily="34" charset="-120"/>
-              </a:rPr>
-              <a:t>회귀 문제에</a:t>
-            </a:r>
-            <a:endParaRPr lang="en-US" sz="1100" dirty="0"/>
-          </a:p>
-          <a:p>
-            <a:pPr marL="0" indent="0">
-              <a:buNone/>
-            </a:pPr>
-            <a:r>
-              <a:rPr lang="en-US" sz="1100" i="1" dirty="0">
-                <a:solidFill>
-                  <a:srgbClr val="7A7974"/>
-                </a:solidFill>
-                <a:latin typeface="Calibri" pitchFamily="34" charset="0"/>
-                <a:ea typeface="Calibri" pitchFamily="34" charset="-122"/>
-                <a:cs typeface="Calibri" pitchFamily="34" charset="-120"/>
-              </a:rPr>
-              <a:t>치명적</a:t>
-            </a:r>
-            <a:endParaRPr lang="en-US" sz="1100" dirty="0"/>
-          </a:p>
-        </p:txBody>
-      </p:sp>
-      <p:sp>
-        <p:nvSpPr>
-          <p:cNvPr id="21" name="Shape 19"/>
-          <p:cNvSpPr/>
-          <p:nvPr/>
-        </p:nvSpPr>
-        <p:spPr>
-          <a:xfrm>
-            <a:off x="4626864" y="1389888"/>
-            <a:ext cx="1920240" cy="3429000"/>
-          </a:xfrm>
-          <a:prstGeom prst="rect">
-            <a:avLst/>
-          </a:prstGeom>
-          <a:solidFill>
-            <a:srgbClr val="FFFFFF"/>
-          </a:solidFill>
-          <a:ln w="12700">
-            <a:solidFill>
-              <a:srgbClr val="D4D1CA"/>
-            </a:solidFill>
-            <a:prstDash val="solid"/>
-          </a:ln>
-          <a:effectLst>
-            <a:outerShdw blurRad="63500" dist="25400" dir="8700000" algn="bl" rotWithShape="0">
-              <a:srgbClr val="28251D">
-                <a:alpha val="7000"/>
-              </a:srgbClr>
-            </a:outerShdw>
-          </a:effectLst>
-        </p:spPr>
-        <p:txBody>
-          <a:bodyPr/>
-          <a:lstStyle/>
-          <a:p>
-            <a:endParaRPr/>
-          </a:p>
-        </p:txBody>
-      </p:sp>
-      <p:sp>
-        <p:nvSpPr>
-          <p:cNvPr id="22" name="Shape 20"/>
-          <p:cNvSpPr/>
-          <p:nvPr/>
-        </p:nvSpPr>
-        <p:spPr>
-          <a:xfrm>
-            <a:off x="4626864" y="1389888"/>
-            <a:ext cx="1920240" cy="73152"/>
-          </a:xfrm>
-          <a:prstGeom prst="rect">
-            <a:avLst/>
-          </a:prstGeom>
-          <a:solidFill>
-            <a:srgbClr val="1B474D"/>
-          </a:solidFill>
-          <a:ln w="12700">
-            <a:solidFill>
-              <a:srgbClr val="1B474D"/>
-            </a:solidFill>
-            <a:prstDash val="solid"/>
-          </a:ln>
-        </p:spPr>
-        <p:txBody>
-          <a:bodyPr/>
-          <a:lstStyle/>
-          <a:p>
-            <a:endParaRPr/>
-          </a:p>
-        </p:txBody>
-      </p:sp>
-      <p:sp>
-        <p:nvSpPr>
-          <p:cNvPr id="23" name="Text 21"/>
-          <p:cNvSpPr/>
-          <p:nvPr/>
-        </p:nvSpPr>
-        <p:spPr>
-          <a:xfrm>
-            <a:off x="4736592" y="1536192"/>
-            <a:ext cx="1700784" cy="384048"/>
-          </a:xfrm>
-          <a:prstGeom prst="rect">
-            <a:avLst/>
-          </a:prstGeom>
-          <a:noFill/>
-          <a:ln/>
-        </p:spPr>
-        <p:txBody>
-          <a:bodyPr wrap="square" lIns="0" tIns="0" rIns="0" bIns="0" rtlCol="0" anchor="ctr"/>
-          <a:lstStyle/>
-          <a:p>
-            <a:pPr marL="0" indent="0">
-              <a:buNone/>
-            </a:pPr>
-            <a:r>
-              <a:rPr lang="en-US" sz="1250" b="1" dirty="0">
-                <a:solidFill>
-                  <a:srgbClr val="28251D"/>
-                </a:solidFill>
-                <a:latin typeface="Trebuchet MS" pitchFamily="34" charset="0"/>
-                <a:ea typeface="Trebuchet MS" pitchFamily="34" charset="-122"/>
-                <a:cs typeface="Trebuchet MS" pitchFamily="34" charset="-120"/>
-              </a:rPr>
-              <a:t>Sin (Siren)</a:t>
-            </a:r>
-            <a:endParaRPr lang="en-US" sz="1250" dirty="0"/>
-          </a:p>
-        </p:txBody>
-      </p:sp>
-      <p:sp>
-        <p:nvSpPr>
-          <p:cNvPr id="24" name="Text 22"/>
-          <p:cNvSpPr/>
-          <p:nvPr/>
-        </p:nvSpPr>
-        <p:spPr>
-          <a:xfrm>
-            <a:off x="4736592" y="2011680"/>
-            <a:ext cx="1700784" cy="201168"/>
-          </a:xfrm>
-          <a:prstGeom prst="rect">
-            <a:avLst/>
-          </a:prstGeom>
-          <a:noFill/>
-          <a:ln/>
-        </p:spPr>
-        <p:txBody>
-          <a:bodyPr wrap="square" lIns="0" tIns="0" rIns="0" bIns="0" rtlCol="0" anchor="ctr"/>
-          <a:lstStyle/>
-          <a:p>
-            <a:pPr marL="0" indent="0">
-              <a:buNone/>
-            </a:pPr>
-            <a:r>
-              <a:rPr lang="en-US" sz="800" b="1" dirty="0">
-                <a:solidFill>
-                  <a:srgbClr val="1B474D"/>
-                </a:solidFill>
-                <a:latin typeface="Calibri" pitchFamily="34" charset="0"/>
-                <a:ea typeface="Calibri" pitchFamily="34" charset="-122"/>
-                <a:cs typeface="Calibri" pitchFamily="34" charset="-120"/>
-              </a:rPr>
-              <a:t>범위 밖 거동</a:t>
-            </a:r>
-            <a:endParaRPr lang="en-US" sz="800" dirty="0"/>
-          </a:p>
-        </p:txBody>
-      </p:sp>
-      <p:sp>
-        <p:nvSpPr>
-          <p:cNvPr id="25" name="Text 23"/>
-          <p:cNvSpPr/>
-          <p:nvPr/>
-        </p:nvSpPr>
-        <p:spPr>
-          <a:xfrm>
-            <a:off x="4736592" y="2231136"/>
-            <a:ext cx="1700784" cy="640080"/>
-          </a:xfrm>
-          <a:prstGeom prst="rect">
-            <a:avLst/>
-          </a:prstGeom>
-          <a:noFill/>
-          <a:ln/>
-        </p:spPr>
-        <p:txBody>
-          <a:bodyPr wrap="square" lIns="0" tIns="0" rIns="0" bIns="0" rtlCol="0" anchor="ctr"/>
-          <a:lstStyle/>
-          <a:p>
-            <a:pPr marL="0" indent="0">
-              <a:buNone/>
-            </a:pPr>
-            <a:r>
-              <a:rPr lang="en-US" sz="1100" dirty="0">
-                <a:solidFill>
-                  <a:srgbClr val="28251D"/>
-                </a:solidFill>
-                <a:latin typeface="Calibri" pitchFamily="34" charset="0"/>
-                <a:ea typeface="Calibri" pitchFamily="34" charset="-122"/>
-                <a:cs typeface="Calibri" pitchFamily="34" charset="-120"/>
-              </a:rPr>
-              <a:t>주기적으로</a:t>
-            </a:r>
-            <a:endParaRPr lang="en-US" sz="1100" dirty="0"/>
-          </a:p>
-          <a:p>
-            <a:pPr marL="0" indent="0">
-              <a:buNone/>
-            </a:pPr>
-            <a:r>
-              <a:rPr lang="en-US" sz="1100" dirty="0">
-                <a:solidFill>
-                  <a:srgbClr val="28251D"/>
-                </a:solidFill>
-                <a:latin typeface="Calibri" pitchFamily="34" charset="0"/>
-                <a:ea typeface="Calibri" pitchFamily="34" charset="-122"/>
-                <a:cs typeface="Calibri" pitchFamily="34" charset="-120"/>
-              </a:rPr>
-              <a:t>계속 반복</a:t>
-            </a:r>
-            <a:endParaRPr lang="en-US" sz="1100" dirty="0"/>
-          </a:p>
-        </p:txBody>
-      </p:sp>
-      <p:sp>
-        <p:nvSpPr>
-          <p:cNvPr id="26" name="Text 24"/>
-          <p:cNvSpPr/>
-          <p:nvPr/>
-        </p:nvSpPr>
-        <p:spPr>
-          <a:xfrm>
-            <a:off x="4736592" y="2971800"/>
-            <a:ext cx="1700784" cy="201168"/>
-          </a:xfrm>
-          <a:prstGeom prst="rect">
-            <a:avLst/>
-          </a:prstGeom>
-          <a:noFill/>
-          <a:ln/>
-        </p:spPr>
-        <p:txBody>
-          <a:bodyPr wrap="square" lIns="0" tIns="0" rIns="0" bIns="0" rtlCol="0" anchor="ctr"/>
-          <a:lstStyle/>
-          <a:p>
-            <a:pPr marL="0" indent="0">
-              <a:buNone/>
-            </a:pPr>
-            <a:r>
-              <a:rPr lang="en-US" sz="800" b="1" dirty="0">
-                <a:solidFill>
-                  <a:srgbClr val="7A7974"/>
-                </a:solidFill>
-                <a:latin typeface="Calibri" pitchFamily="34" charset="0"/>
-                <a:ea typeface="Calibri" pitchFamily="34" charset="-122"/>
-                <a:cs typeface="Calibri" pitchFamily="34" charset="-120"/>
-              </a:rPr>
-              <a:t>함의</a:t>
-            </a:r>
-            <a:endParaRPr lang="en-US" sz="800" dirty="0"/>
-          </a:p>
-        </p:txBody>
-      </p:sp>
-      <p:sp>
-        <p:nvSpPr>
-          <p:cNvPr id="27" name="Text 25"/>
-          <p:cNvSpPr/>
-          <p:nvPr/>
-        </p:nvSpPr>
-        <p:spPr>
-          <a:xfrm>
-            <a:off x="4736592" y="3191256"/>
-            <a:ext cx="1700784" cy="594360"/>
-          </a:xfrm>
-          <a:prstGeom prst="rect">
-            <a:avLst/>
-          </a:prstGeom>
-          <a:noFill/>
-          <a:ln/>
-        </p:spPr>
-        <p:txBody>
-          <a:bodyPr wrap="square" lIns="0" tIns="0" rIns="0" bIns="0" rtlCol="0" anchor="ctr"/>
-          <a:lstStyle/>
-          <a:p>
-            <a:pPr marL="0" indent="0">
-              <a:buNone/>
-            </a:pPr>
-            <a:r>
-              <a:rPr lang="en-US" sz="1100" i="1" dirty="0">
-                <a:solidFill>
-                  <a:srgbClr val="7A7974"/>
-                </a:solidFill>
-                <a:latin typeface="Calibri" pitchFamily="34" charset="0"/>
-                <a:ea typeface="Calibri" pitchFamily="34" charset="-122"/>
-                <a:cs typeface="Calibri" pitchFamily="34" charset="-120"/>
-              </a:rPr>
-              <a:t>물리 해석 가능</a:t>
-            </a:r>
-            <a:endParaRPr lang="en-US" sz="1100" dirty="0"/>
-          </a:p>
-          <a:p>
-            <a:pPr marL="0" indent="0">
-              <a:buNone/>
-            </a:pPr>
-            <a:r>
-              <a:rPr lang="en-US" sz="1100" i="1" dirty="0">
-                <a:solidFill>
-                  <a:srgbClr val="7A7974"/>
-                </a:solidFill>
-                <a:latin typeface="Calibri" pitchFamily="34" charset="0"/>
-                <a:ea typeface="Calibri" pitchFamily="34" charset="-122"/>
-                <a:cs typeface="Calibri" pitchFamily="34" charset="-120"/>
-              </a:rPr>
-              <a:t>과적합 위험</a:t>
-            </a:r>
-            <a:endParaRPr lang="en-US" sz="1100" dirty="0"/>
-          </a:p>
-        </p:txBody>
-      </p:sp>
-      <p:sp>
-        <p:nvSpPr>
-          <p:cNvPr id="28" name="Shape 26"/>
-          <p:cNvSpPr/>
-          <p:nvPr/>
-        </p:nvSpPr>
-        <p:spPr>
-          <a:xfrm>
-            <a:off x="6711696" y="1389888"/>
-            <a:ext cx="1920240" cy="3429000"/>
-          </a:xfrm>
-          <a:prstGeom prst="rect">
-            <a:avLst/>
-          </a:prstGeom>
-          <a:solidFill>
-            <a:srgbClr val="FFFFFF"/>
-          </a:solidFill>
-          <a:ln w="12700">
-            <a:solidFill>
-              <a:srgbClr val="D4D1CA"/>
-            </a:solidFill>
-            <a:prstDash val="solid"/>
-          </a:ln>
-          <a:effectLst>
-            <a:outerShdw blurRad="63500" dist="25400" dir="8700000" algn="bl" rotWithShape="0">
-              <a:srgbClr val="28251D">
-                <a:alpha val="7000"/>
-              </a:srgbClr>
-            </a:outerShdw>
-          </a:effectLst>
-        </p:spPr>
-        <p:txBody>
-          <a:bodyPr/>
-          <a:lstStyle/>
-          <a:p>
-            <a:endParaRPr/>
-          </a:p>
-        </p:txBody>
-      </p:sp>
-      <p:sp>
-        <p:nvSpPr>
-          <p:cNvPr id="29" name="Shape 27"/>
-          <p:cNvSpPr/>
-          <p:nvPr/>
-        </p:nvSpPr>
-        <p:spPr>
-          <a:xfrm>
-            <a:off x="6711696" y="1389888"/>
-            <a:ext cx="1920240" cy="73152"/>
-          </a:xfrm>
-          <a:prstGeom prst="rect">
-            <a:avLst/>
-          </a:prstGeom>
-          <a:solidFill>
-            <a:srgbClr val="7A7974"/>
-          </a:solidFill>
-          <a:ln w="12700">
-            <a:solidFill>
-              <a:srgbClr val="7A7974"/>
-            </a:solidFill>
-            <a:prstDash val="solid"/>
-          </a:ln>
-        </p:spPr>
-        <p:txBody>
-          <a:bodyPr/>
-          <a:lstStyle/>
-          <a:p>
-            <a:endParaRPr/>
-          </a:p>
-        </p:txBody>
-      </p:sp>
-      <p:sp>
-        <p:nvSpPr>
-          <p:cNvPr id="30" name="Text 28"/>
-          <p:cNvSpPr/>
-          <p:nvPr/>
-        </p:nvSpPr>
-        <p:spPr>
-          <a:xfrm>
-            <a:off x="6821424" y="1536192"/>
-            <a:ext cx="1700784" cy="384048"/>
-          </a:xfrm>
-          <a:prstGeom prst="rect">
-            <a:avLst/>
-          </a:prstGeom>
-          <a:noFill/>
-          <a:ln/>
-        </p:spPr>
-        <p:txBody>
-          <a:bodyPr wrap="square" lIns="0" tIns="0" rIns="0" bIns="0" rtlCol="0" anchor="ctr"/>
-          <a:lstStyle/>
-          <a:p>
-            <a:pPr marL="0" indent="0">
-              <a:buNone/>
-            </a:pPr>
-            <a:r>
-              <a:rPr lang="en-US" sz="1250" b="1" dirty="0">
-                <a:solidFill>
-                  <a:srgbClr val="28251D"/>
-                </a:solidFill>
-                <a:latin typeface="Trebuchet MS" pitchFamily="34" charset="0"/>
-                <a:ea typeface="Trebuchet MS" pitchFamily="34" charset="-122"/>
-                <a:cs typeface="Trebuchet MS" pitchFamily="34" charset="-120"/>
-              </a:rPr>
-              <a:t>ELU / GELU</a:t>
-            </a:r>
-            <a:endParaRPr lang="en-US" sz="1250" dirty="0"/>
-          </a:p>
-        </p:txBody>
-      </p:sp>
-      <p:sp>
-        <p:nvSpPr>
-          <p:cNvPr id="31" name="Text 29"/>
-          <p:cNvSpPr/>
-          <p:nvPr/>
-        </p:nvSpPr>
-        <p:spPr>
-          <a:xfrm>
-            <a:off x="6821424" y="2011680"/>
-            <a:ext cx="1700784" cy="201168"/>
-          </a:xfrm>
-          <a:prstGeom prst="rect">
-            <a:avLst/>
-          </a:prstGeom>
-          <a:noFill/>
-          <a:ln/>
-        </p:spPr>
-        <p:txBody>
-          <a:bodyPr wrap="square" lIns="0" tIns="0" rIns="0" bIns="0" rtlCol="0" anchor="ctr"/>
-          <a:lstStyle/>
-          <a:p>
-            <a:pPr marL="0" indent="0">
-              <a:buNone/>
-            </a:pPr>
-            <a:r>
-              <a:rPr lang="en-US" sz="800" b="1" dirty="0">
-                <a:solidFill>
-                  <a:srgbClr val="7A7974"/>
-                </a:solidFill>
-                <a:latin typeface="Calibri" pitchFamily="34" charset="0"/>
-                <a:ea typeface="Calibri" pitchFamily="34" charset="-122"/>
-                <a:cs typeface="Calibri" pitchFamily="34" charset="-120"/>
-              </a:rPr>
-              <a:t>범위 밖 거동</a:t>
-            </a:r>
-            <a:endParaRPr lang="en-US" sz="800" dirty="0"/>
-          </a:p>
-        </p:txBody>
-      </p:sp>
-      <p:sp>
-        <p:nvSpPr>
-          <p:cNvPr id="32" name="Text 30"/>
-          <p:cNvSpPr/>
-          <p:nvPr/>
-        </p:nvSpPr>
-        <p:spPr>
-          <a:xfrm>
-            <a:off x="6821424" y="2231136"/>
-            <a:ext cx="1700784" cy="640080"/>
-          </a:xfrm>
-          <a:prstGeom prst="rect">
-            <a:avLst/>
-          </a:prstGeom>
-          <a:noFill/>
-          <a:ln/>
-        </p:spPr>
-        <p:txBody>
-          <a:bodyPr wrap="square" lIns="0" tIns="0" rIns="0" bIns="0" rtlCol="0" anchor="ctr"/>
-          <a:lstStyle/>
-          <a:p>
-            <a:pPr marL="0" indent="0">
-              <a:buNone/>
-            </a:pPr>
-            <a:r>
-              <a:rPr lang="en-US" sz="1100" dirty="0">
-                <a:solidFill>
-                  <a:srgbClr val="28251D"/>
-                </a:solidFill>
-                <a:latin typeface="Calibri" pitchFamily="34" charset="0"/>
-                <a:ea typeface="Calibri" pitchFamily="34" charset="-122"/>
-                <a:cs typeface="Calibri" pitchFamily="34" charset="-120"/>
-              </a:rPr>
-              <a:t>좌측 포화,</a:t>
-            </a:r>
-            <a:endParaRPr lang="en-US" sz="1100" dirty="0"/>
-          </a:p>
-          <a:p>
-            <a:pPr marL="0" indent="0">
-              <a:buNone/>
-            </a:pPr>
-            <a:r>
-              <a:rPr lang="en-US" sz="1100" dirty="0">
-                <a:solidFill>
-                  <a:srgbClr val="28251D"/>
-                </a:solidFill>
-                <a:latin typeface="Calibri" pitchFamily="34" charset="0"/>
-                <a:ea typeface="Calibri" pitchFamily="34" charset="-122"/>
-                <a:cs typeface="Calibri" pitchFamily="34" charset="-120"/>
-              </a:rPr>
-              <a:t>우측 선형</a:t>
-            </a:r>
-            <a:endParaRPr lang="en-US" sz="1100" dirty="0"/>
-          </a:p>
-        </p:txBody>
-      </p:sp>
-      <p:sp>
-        <p:nvSpPr>
-          <p:cNvPr id="33" name="Text 31"/>
-          <p:cNvSpPr/>
-          <p:nvPr/>
-        </p:nvSpPr>
-        <p:spPr>
-          <a:xfrm>
-            <a:off x="6821424" y="2971800"/>
-            <a:ext cx="1700784" cy="201168"/>
-          </a:xfrm>
-          <a:prstGeom prst="rect">
-            <a:avLst/>
-          </a:prstGeom>
-          <a:noFill/>
-          <a:ln/>
-        </p:spPr>
-        <p:txBody>
-          <a:bodyPr wrap="square" lIns="0" tIns="0" rIns="0" bIns="0" rtlCol="0" anchor="ctr"/>
-          <a:lstStyle/>
-          <a:p>
-            <a:pPr marL="0" indent="0">
-              <a:buNone/>
-            </a:pPr>
-            <a:r>
-              <a:rPr lang="en-US" sz="800" b="1" dirty="0">
-                <a:solidFill>
-                  <a:srgbClr val="7A7974"/>
-                </a:solidFill>
-                <a:latin typeface="Calibri" pitchFamily="34" charset="0"/>
-                <a:ea typeface="Calibri" pitchFamily="34" charset="-122"/>
-                <a:cs typeface="Calibri" pitchFamily="34" charset="-120"/>
-              </a:rPr>
-              <a:t>함의</a:t>
-            </a:r>
-            <a:endParaRPr lang="en-US" sz="800" dirty="0"/>
-          </a:p>
-        </p:txBody>
-      </p:sp>
-      <p:sp>
-        <p:nvSpPr>
-          <p:cNvPr id="34" name="Text 32"/>
-          <p:cNvSpPr/>
-          <p:nvPr/>
-        </p:nvSpPr>
-        <p:spPr>
-          <a:xfrm>
-            <a:off x="6821424" y="3191256"/>
-            <a:ext cx="1700784" cy="594360"/>
-          </a:xfrm>
-          <a:prstGeom prst="rect">
-            <a:avLst/>
-          </a:prstGeom>
-          <a:noFill/>
-          <a:ln/>
-        </p:spPr>
-        <p:txBody>
-          <a:bodyPr wrap="square" lIns="0" tIns="0" rIns="0" bIns="0" rtlCol="0" anchor="ctr"/>
-          <a:lstStyle/>
-          <a:p>
-            <a:pPr marL="0" indent="0">
-              <a:buNone/>
-            </a:pPr>
-            <a:r>
-              <a:rPr lang="en-US" sz="1100" i="1" dirty="0">
-                <a:solidFill>
-                  <a:srgbClr val="7A7974"/>
-                </a:solidFill>
-                <a:latin typeface="Calibri" pitchFamily="34" charset="0"/>
-                <a:ea typeface="Calibri" pitchFamily="34" charset="-122"/>
-                <a:cs typeface="Calibri" pitchFamily="34" charset="-120"/>
-              </a:rPr>
-              <a:t>ReLU보다</a:t>
-            </a:r>
-            <a:endParaRPr lang="en-US" sz="1100" dirty="0"/>
-          </a:p>
-          <a:p>
-            <a:pPr marL="0" indent="0">
-              <a:buNone/>
-            </a:pPr>
-            <a:r>
-              <a:rPr lang="en-US" sz="1100" i="1" dirty="0">
-                <a:solidFill>
-                  <a:srgbClr val="7A7974"/>
-                </a:solidFill>
-                <a:latin typeface="Calibri" pitchFamily="34" charset="0"/>
-                <a:ea typeface="Calibri" pitchFamily="34" charset="-122"/>
-                <a:cs typeface="Calibri" pitchFamily="34" charset="-120"/>
-              </a:rPr>
-              <a:t>약간 나음</a:t>
-            </a:r>
-            <a:endParaRPr lang="en-US" sz="1100" dirty="0"/>
-          </a:p>
-        </p:txBody>
-      </p:sp>
-      <p:sp>
-        <p:nvSpPr>
-          <p:cNvPr id="35" name="Shape 33"/>
-          <p:cNvSpPr/>
-          <p:nvPr/>
-        </p:nvSpPr>
-        <p:spPr>
-          <a:xfrm>
-            <a:off x="457200" y="4754880"/>
-            <a:ext cx="64008" cy="201168"/>
-          </a:xfrm>
-          <a:prstGeom prst="rect">
-            <a:avLst/>
-          </a:prstGeom>
-          <a:solidFill>
-            <a:srgbClr val="01696F"/>
-          </a:solidFill>
-          <a:ln w="12700">
-            <a:solidFill>
-              <a:srgbClr val="01696F"/>
-            </a:solidFill>
-            <a:prstDash val="solid"/>
-          </a:ln>
-        </p:spPr>
-        <p:txBody>
-          <a:bodyPr/>
-          <a:lstStyle/>
-          <a:p>
-            <a:endParaRPr/>
-          </a:p>
-        </p:txBody>
-      </p:sp>
-      <p:sp>
-        <p:nvSpPr>
-          <p:cNvPr id="36" name="Shape 34"/>
-          <p:cNvSpPr/>
-          <p:nvPr/>
-        </p:nvSpPr>
-        <p:spPr>
-          <a:xfrm>
-            <a:off x="521208" y="4754880"/>
-            <a:ext cx="8165592" cy="201168"/>
-          </a:xfrm>
-          <a:prstGeom prst="rect">
-            <a:avLst/>
-          </a:prstGeom>
-          <a:solidFill>
-            <a:srgbClr val="E8F4F5"/>
-          </a:solidFill>
-          <a:ln w="12700">
-            <a:solidFill>
-              <a:srgbClr val="E8F4F5"/>
-            </a:solidFill>
-            <a:prstDash val="solid"/>
-          </a:ln>
-        </p:spPr>
-        <p:txBody>
-          <a:bodyPr/>
-          <a:lstStyle/>
-          <a:p>
-            <a:endParaRPr/>
-          </a:p>
-        </p:txBody>
-      </p:sp>
-      <p:sp>
-        <p:nvSpPr>
-          <p:cNvPr id="37" name="Text 35"/>
-          <p:cNvSpPr/>
-          <p:nvPr/>
-        </p:nvSpPr>
-        <p:spPr>
-          <a:xfrm>
-            <a:off x="640080" y="4773168"/>
-            <a:ext cx="8046720" cy="164592"/>
-          </a:xfrm>
-          <a:prstGeom prst="rect">
-            <a:avLst/>
-          </a:prstGeom>
-          <a:noFill/>
-          <a:ln/>
-        </p:spPr>
-        <p:txBody>
-          <a:bodyPr wrap="square" lIns="0" tIns="0" rIns="0" bIns="0" rtlCol="0" anchor="ctr"/>
-          <a:lstStyle/>
-          <a:p>
-            <a:pPr marL="0" indent="0">
-              <a:buNone/>
-            </a:pPr>
-            <a:r>
-              <a:rPr lang="en-US" sz="900" b="1" dirty="0">
-                <a:solidFill>
-                  <a:srgbClr val="0C4E54"/>
-                </a:solidFill>
-                <a:latin typeface="Calibri" pitchFamily="34" charset="0"/>
-                <a:ea typeface="Calibri" pitchFamily="34" charset="-122"/>
-                <a:cs typeface="Calibri" pitchFamily="34" charset="-120"/>
-              </a:rPr>
-              <a:t>핵심 발견: 활성화 함수 선택이 외삽 거동을 결정 — 물리 지식 없이 범위 밖 예측 불가능</a:t>
-            </a:r>
-            <a:endParaRPr lang="en-US" sz="900" dirty="0"/>
-          </a:p>
-        </p:txBody>
-      </p:sp>
-      <p:sp>
-        <p:nvSpPr>
-          <p:cNvPr id="38" name="Text 36"/>
-          <p:cNvSpPr/>
-          <p:nvPr/>
-        </p:nvSpPr>
-        <p:spPr>
-          <a:xfrm>
-            <a:off x="457200" y="5001768"/>
-            <a:ext cx="8686800" cy="146304"/>
-          </a:xfrm>
-          <a:prstGeom prst="rect">
-            <a:avLst/>
-          </a:prstGeom>
-          <a:noFill/>
-          <a:ln/>
-        </p:spPr>
-        <p:txBody>
-          <a:bodyPr wrap="square" lIns="0" tIns="0" rIns="0" bIns="0" rtlCol="0" anchor="ctr"/>
-          <a:lstStyle/>
-          <a:p>
-            <a:pPr marL="0" indent="0">
-              <a:buNone/>
-            </a:pPr>
-            <a:r>
-              <a:rPr lang="en-US" sz="750" i="1" dirty="0">
-                <a:solidFill>
-                  <a:srgbClr val="7A7974"/>
-                </a:solidFill>
-                <a:latin typeface="Calibri" pitchFamily="34" charset="0"/>
-                <a:ea typeface="Calibri" pitchFamily="34" charset="-122"/>
-                <a:cs typeface="Calibri" pitchFamily="34" charset="-120"/>
-              </a:rPr>
-              <a:t>Xu et al. (2021) “How Neural Networks Extrapolate: From Feedforward to GNN” · arxiv:2009.11848</a:t>
-            </a:r>
-            <a:endParaRPr lang="en-US" sz="750" dirty="0"/>
-          </a:p>
-        </p:txBody>
-      </p:sp>
-      <p:sp>
-        <p:nvSpPr>
-          <p:cNvPr id="39" name="Rounded Rectangle 38"/>
-          <p:cNvSpPr/>
-          <p:nvPr/>
-        </p:nvSpPr>
-        <p:spPr>
-          <a:xfrm>
-            <a:off x="365760" y="5623560"/>
-            <a:ext cx="8412480" cy="868680"/>
-          </a:xfrm>
-          <a:prstGeom prst="roundRect">
-            <a:avLst/>
-          </a:prstGeom>
-          <a:solidFill>
-            <a:srgbClr val="F0F4F8"/>
+            <a:srgbClr val="1A2B4B"/>
           </a:solidFill>
           <a:ln>
-            <a:solidFill>
-              <a:srgbClr val="2E86AB"/>
-            </a:solidFill>
+            <a:noFill/>
           </a:ln>
         </p:spPr>
         <p:style>
@@ -15817,26 +14415,363 @@
           </a:fontRef>
         </p:style>
         <p:txBody>
-          <a:bodyPr wrap="square" rtlCol="0" anchor="ctr"/>
+          <a:bodyPr rtlCol="0" anchor="ctr"/>
           <a:lstStyle/>
           <a:p>
             <a:pPr algn="ctr"/>
-            <a:r>
-              <a:rPr sz="1000" b="1">
+          </a:p>
+        </p:txBody>
+      </p:sp>
+      <p:sp>
+        <p:nvSpPr>
+          <p:cNvPr id="3" name="TextBox 2"/>
+          <p:cNvSpPr txBox="1"/>
+          <p:nvPr/>
+        </p:nvSpPr>
+        <p:spPr>
+          <a:xfrm>
+            <a:off x="365760" y="109728"/>
+            <a:ext cx="8412480" cy="256032"/>
+          </a:xfrm>
+          <a:prstGeom prst="rect">
+            <a:avLst/>
+          </a:prstGeom>
+          <a:noFill/>
+        </p:spPr>
+        <p:txBody>
+          <a:bodyPr wrap="none">
+            <a:spAutoFit/>
+          </a:bodyPr>
+          <a:lstStyle/>
+          <a:p>
+            <a:r>
+              <a:rPr sz="1100" b="1">
                 <a:solidFill>
                   <a:srgbClr val="2E86AB"/>
                 </a:solidFill>
-              </a:rPr>
-              <a:t>PART 3 · 핵심 정리  |  </a:t>
-            </a:r>
-            <a:r>
-              <a:rPr sz="1000">
-                <a:solidFill>
-                  <a:srgbClr val="555555"/>
-                </a:solidFill>
-              </a:rPr>
-              <a:t>Xu (2021) 결론: NN 외삽 실패는 "학습 부족"이 아니라 "활성화 함수 구조" 문제.
-ReLU MLP는 범위 밖에서 선형 연장 -&gt; 곡률 없음. 해결 = EQL/NALU/Monotonic/PINN 등 구조적 제약.</a:t>
+                <a:latin typeface="맑은 고딕"/>
+              </a:rPr>
+              <a:t>PART 3  ·  신경망 외삽</a:t>
+            </a:r>
+          </a:p>
+        </p:txBody>
+      </p:sp>
+      <p:sp>
+        <p:nvSpPr>
+          <p:cNvPr id="4" name="TextBox 3"/>
+          <p:cNvSpPr txBox="1"/>
+          <p:nvPr/>
+        </p:nvSpPr>
+        <p:spPr>
+          <a:xfrm>
+            <a:off x="365760" y="329184"/>
+            <a:ext cx="8412480" cy="384048"/>
+          </a:xfrm>
+          <a:prstGeom prst="rect">
+            <a:avLst/>
+          </a:prstGeom>
+          <a:noFill/>
+        </p:spPr>
+        <p:txBody>
+          <a:bodyPr wrap="none">
+            <a:spAutoFit/>
+          </a:bodyPr>
+          <a:lstStyle/>
+          <a:p>
+            <a:r>
+              <a:rPr sz="2200" b="1">
+                <a:solidFill>
+                  <a:srgbClr val="1A2B4B"/>
+                </a:solidFill>
+                <a:latin typeface="맑은 고딕"/>
+              </a:rPr>
+              <a:t>활성화 함수가 외삽 거동을 결정한다</a:t>
+            </a:r>
+          </a:p>
+        </p:txBody>
+      </p:sp>
+      <p:pic>
+        <p:nvPicPr>
+          <p:cNvPr id="5" name="Picture 4" descr="04_activation_hq.png"/>
+          <p:cNvPicPr>
+            <a:picLocks noChangeAspect="1"/>
+          </p:cNvPicPr>
+          <p:nvPr/>
+        </p:nvPicPr>
+        <p:blipFill>
+          <a:blip r:embed="rId3"/>
+          <a:stretch>
+            <a:fillRect/>
+          </a:stretch>
+        </p:blipFill>
+        <p:spPr>
+          <a:xfrm>
+            <a:off x="365760" y="822960"/>
+            <a:ext cx="8412480" cy="2634211"/>
+          </a:xfrm>
+          <a:prstGeom prst="rect">
+            <a:avLst/>
+          </a:prstGeom>
+        </p:spPr>
+      </p:pic>
+      <p:sp>
+        <p:nvSpPr>
+          <p:cNvPr id="6" name="Rounded Rectangle 5"/>
+          <p:cNvSpPr/>
+          <p:nvPr/>
+        </p:nvSpPr>
+        <p:spPr>
+          <a:xfrm>
+            <a:off x="365760" y="3703320"/>
+            <a:ext cx="2697480" cy="868680"/>
+          </a:xfrm>
+          <a:prstGeom prst="roundRect">
+            <a:avLst/>
+          </a:prstGeom>
+          <a:solidFill>
+            <a:srgbClr val="F4F7FA"/>
+          </a:solidFill>
+          <a:ln>
+            <a:solidFill>
+              <a:srgbClr val="E8F1F8"/>
+            </a:solidFill>
+          </a:ln>
+        </p:spPr>
+        <p:style>
+          <a:lnRef idx="1">
+            <a:schemeClr val="accent1"/>
+          </a:lnRef>
+          <a:fillRef idx="3">
+            <a:schemeClr val="accent1"/>
+          </a:fillRef>
+          <a:effectRef idx="2">
+            <a:schemeClr val="accent1"/>
+          </a:effectRef>
+          <a:fontRef idx="minor">
+            <a:schemeClr val="lt1"/>
+          </a:fontRef>
+        </p:style>
+        <p:txBody>
+          <a:bodyPr rtlCol="0" anchor="ctr" wrap="square" lIns="109728" tIns="73152"/>
+          <a:lstStyle/>
+          <a:p>
+            <a:pPr algn="ctr"/>
+            <a:r>
+              <a:rPr sz="1300" b="1">
+                <a:solidFill>
+                  <a:srgbClr val="2E86AB"/>
+                </a:solidFill>
+                <a:latin typeface="맑은 고딕"/>
+              </a:rPr>
+              <a:t>ReLU</a:t>
+            </a:r>
+          </a:p>
+          <a:p>
+            <a:r>
+              <a:rPr sz="1100" b="0">
+                <a:solidFill>
+                  <a:srgbClr val="1A2B4B"/>
+                </a:solidFill>
+                <a:latin typeface="맑은 고딕"/>
+              </a:rPr>
+              <a:t>방향별 조각 선형화 (Thm.1)</a:t>
+            </a:r>
+          </a:p>
+          <a:p>
+            <a:r>
+              <a:rPr sz="1000" b="0">
+                <a:solidFill>
+                  <a:srgbClr val="5A5A5A"/>
+                </a:solidFill>
+                <a:latin typeface="맑은 고딕"/>
+              </a:rPr>
+              <a:t>비선형 타깃 외삽 실패</a:t>
+            </a:r>
+          </a:p>
+        </p:txBody>
+      </p:sp>
+      <p:sp>
+        <p:nvSpPr>
+          <p:cNvPr id="7" name="Rounded Rectangle 6"/>
+          <p:cNvSpPr/>
+          <p:nvPr/>
+        </p:nvSpPr>
+        <p:spPr>
+          <a:xfrm>
+            <a:off x="3200400" y="3703320"/>
+            <a:ext cx="2697480" cy="868680"/>
+          </a:xfrm>
+          <a:prstGeom prst="roundRect">
+            <a:avLst/>
+          </a:prstGeom>
+          <a:solidFill>
+            <a:srgbClr val="F4F7FA"/>
+          </a:solidFill>
+          <a:ln>
+            <a:solidFill>
+              <a:srgbClr val="E8F1F8"/>
+            </a:solidFill>
+          </a:ln>
+        </p:spPr>
+        <p:style>
+          <a:lnRef idx="1">
+            <a:schemeClr val="accent1"/>
+          </a:lnRef>
+          <a:fillRef idx="3">
+            <a:schemeClr val="accent1"/>
+          </a:fillRef>
+          <a:effectRef idx="2">
+            <a:schemeClr val="accent1"/>
+          </a:effectRef>
+          <a:fontRef idx="minor">
+            <a:schemeClr val="lt1"/>
+          </a:fontRef>
+        </p:style>
+        <p:txBody>
+          <a:bodyPr rtlCol="0" anchor="ctr" wrap="square" lIns="109728" tIns="73152"/>
+          <a:lstStyle/>
+          <a:p>
+            <a:pPr algn="ctr"/>
+            <a:r>
+              <a:rPr sz="1300" b="1">
+                <a:solidFill>
+                  <a:srgbClr val="2E86AB"/>
+                </a:solidFill>
+                <a:latin typeface="맑은 고딕"/>
+              </a:rPr>
+              <a:t>Tanh</a:t>
+            </a:r>
+          </a:p>
+          <a:p>
+            <a:r>
+              <a:rPr sz="1100" b="0">
+                <a:solidFill>
+                  <a:srgbClr val="1A2B4B"/>
+                </a:solidFill>
+                <a:latin typeface="맑은 고딕"/>
+              </a:rPr>
+              <a:t>포화 → 상수 수렴</a:t>
+            </a:r>
+          </a:p>
+          <a:p>
+            <a:r>
+              <a:rPr sz="1000" b="0">
+                <a:solidFill>
+                  <a:srgbClr val="5A5A5A"/>
+                </a:solidFill>
+                <a:latin typeface="맑은 고딕"/>
+              </a:rPr>
+              <a:t>회귀 외삽에 치명적</a:t>
+            </a:r>
+          </a:p>
+        </p:txBody>
+      </p:sp>
+      <p:sp>
+        <p:nvSpPr>
+          <p:cNvPr id="8" name="Rounded Rectangle 7"/>
+          <p:cNvSpPr/>
+          <p:nvPr/>
+        </p:nvSpPr>
+        <p:spPr>
+          <a:xfrm>
+            <a:off x="6035040" y="3703320"/>
+            <a:ext cx="2697480" cy="868680"/>
+          </a:xfrm>
+          <a:prstGeom prst="roundRect">
+            <a:avLst/>
+          </a:prstGeom>
+          <a:solidFill>
+            <a:srgbClr val="F4F7FA"/>
+          </a:solidFill>
+          <a:ln>
+            <a:solidFill>
+              <a:srgbClr val="E8F1F8"/>
+            </a:solidFill>
+          </a:ln>
+        </p:spPr>
+        <p:style>
+          <a:lnRef idx="1">
+            <a:schemeClr val="accent1"/>
+          </a:lnRef>
+          <a:fillRef idx="3">
+            <a:schemeClr val="accent1"/>
+          </a:fillRef>
+          <a:effectRef idx="2">
+            <a:schemeClr val="accent1"/>
+          </a:effectRef>
+          <a:fontRef idx="minor">
+            <a:schemeClr val="lt1"/>
+          </a:fontRef>
+        </p:style>
+        <p:txBody>
+          <a:bodyPr rtlCol="0" anchor="ctr" wrap="square" lIns="109728" tIns="73152"/>
+          <a:lstStyle/>
+          <a:p>
+            <a:pPr algn="ctr"/>
+            <a:r>
+              <a:rPr sz="1300" b="1">
+                <a:solidFill>
+                  <a:srgbClr val="2E86AB"/>
+                </a:solidFill>
+                <a:latin typeface="맑은 고딕"/>
+              </a:rPr>
+              <a:t>Sin</a:t>
+            </a:r>
+          </a:p>
+          <a:p>
+            <a:r>
+              <a:rPr sz="1100" b="0">
+                <a:solidFill>
+                  <a:srgbClr val="1A2B4B"/>
+                </a:solidFill>
+                <a:latin typeface="맑은 고딕"/>
+              </a:rPr>
+              <a:t>주기 반복</a:t>
+            </a:r>
+          </a:p>
+          <a:p>
+            <a:r>
+              <a:rPr sz="1000" b="0">
+                <a:solidFill>
+                  <a:srgbClr val="5A5A5A"/>
+                </a:solidFill>
+                <a:latin typeface="맑은 고딕"/>
+              </a:rPr>
+              <a:t>물리 해석 가능 / 과적합 위험</a:t>
+            </a:r>
+          </a:p>
+        </p:txBody>
+      </p:sp>
+      <p:sp>
+        <p:nvSpPr>
+          <p:cNvPr id="9" name="TextBox 8"/>
+          <p:cNvSpPr txBox="1"/>
+          <p:nvPr/>
+        </p:nvSpPr>
+        <p:spPr>
+          <a:xfrm>
+            <a:off x="365760" y="4773168"/>
+            <a:ext cx="8412480" cy="256032"/>
+          </a:xfrm>
+          <a:prstGeom prst="rect">
+            <a:avLst/>
+          </a:prstGeom>
+          <a:noFill/>
+        </p:spPr>
+        <p:txBody>
+          <a:bodyPr wrap="none">
+            <a:spAutoFit/>
+          </a:bodyPr>
+          <a:lstStyle/>
+          <a:p>
+            <a:r>
+              <a:rPr sz="1000" b="0">
+                <a:solidFill>
+                  <a:srgbClr val="5A5A5A"/>
+                </a:solidFill>
+                <a:latin typeface="맑은 고딕"/>
+              </a:rPr>
+              <a:t>핵심: 활성화 선택 = 외삽 가정 선택  ·  Xu et al. (2021) §3.3</a:t>
             </a:r>
           </a:p>
         </p:txBody>
@@ -20262,8 +19197,8 @@
         </p:nvSpPr>
         <p:spPr>
           <a:xfrm>
-            <a:off x="365760" y="5623560"/>
-            <a:ext cx="8412480" cy="868680"/>
+            <a:off x="365760" y="4773168"/>
+            <a:ext cx="8412480" cy="256032"/>
           </a:xfrm>
           <a:prstGeom prst="roundRect">
             <a:avLst/>
@@ -23974,7 +22909,7 @@
         <p:spPr>
           <a:xfrm>
             <a:off x="-1097280" y="2926080"/>
-            <a:ext cx="3200400" cy="3200400"/>
+            <a:ext cx="3200400" cy="2197420"/>
           </a:xfrm>
           <a:prstGeom prst="ellipse">
             <a:avLst/>
@@ -24241,7 +23176,6 @@
           <a:lstStyle/>
           <a:p>
             <a:pPr algn="ctr"/>
-            <a:endParaRPr/>
           </a:p>
         </p:txBody>
       </p:sp>
@@ -24356,7 +23290,7 @@
         <p:spPr>
           <a:xfrm>
             <a:off x="274320" y="3429000"/>
-            <a:ext cx="4206240" cy="2086429"/>
+            <a:ext cx="4206240" cy="1694500"/>
           </a:xfrm>
           <a:prstGeom prst="rect">
             <a:avLst/>
@@ -24372,7 +23306,7 @@
         <p:spPr>
           <a:xfrm>
             <a:off x="4617720" y="1051560"/>
-            <a:ext cx="4206240" cy="4846320"/>
+            <a:ext cx="4206240" cy="4071940"/>
           </a:xfrm>
           <a:prstGeom prst="rect">
             <a:avLst/>
@@ -24484,8 +23418,8 @@
         </p:nvSpPr>
         <p:spPr>
           <a:xfrm>
-            <a:off x="457200" y="5989320"/>
-            <a:ext cx="8229600" cy="320040"/>
+            <a:off x="457200" y="4773168"/>
+            <a:ext cx="8229600" cy="256032"/>
           </a:xfrm>
           <a:prstGeom prst="rect">
             <a:avLst/>
@@ -24584,7 +23518,6 @@
           <a:lstStyle/>
           <a:p>
             <a:pPr algn="ctr"/>
-            <a:endParaRPr/>
           </a:p>
         </p:txBody>
       </p:sp>
@@ -24699,7 +23632,7 @@
         <p:spPr>
           <a:xfrm>
             <a:off x="274320" y="3429000"/>
-            <a:ext cx="4206240" cy="1819366"/>
+            <a:ext cx="4206240" cy="1694500"/>
           </a:xfrm>
           <a:prstGeom prst="rect">
             <a:avLst/>
@@ -24715,7 +23648,7 @@
         <p:spPr>
           <a:xfrm>
             <a:off x="4617720" y="1051560"/>
-            <a:ext cx="4206240" cy="4846320"/>
+            <a:ext cx="4206240" cy="4071940"/>
           </a:xfrm>
           <a:prstGeom prst="rect">
             <a:avLst/>
@@ -24887,8 +23820,8 @@
         </p:nvSpPr>
         <p:spPr>
           <a:xfrm>
-            <a:off x="457200" y="5989320"/>
-            <a:ext cx="8229600" cy="320040"/>
+            <a:off x="457200" y="4773168"/>
+            <a:ext cx="8229600" cy="256032"/>
           </a:xfrm>
           <a:prstGeom prst="rect">
             <a:avLst/>
@@ -24922,8 +23855,8 @@
         </p:nvSpPr>
         <p:spPr>
           <a:xfrm>
-            <a:off x="365760" y="5486400"/>
-            <a:ext cx="8412480" cy="502920"/>
+            <a:off x="365760" y="4526280"/>
+            <a:ext cx="8412480" cy="320040"/>
           </a:xfrm>
           <a:prstGeom prst="roundRect">
             <a:avLst/>
@@ -24952,7 +23885,7 @@
           </a:fontRef>
         </p:style>
         <p:txBody>
-          <a:bodyPr wrap="square" rtlCol="0" anchor="ctr"/>
+          <a:bodyPr rtlCol="0" anchor="ctr" wrap="square"/>
           <a:lstStyle/>
           <a:p>
             <a:pPr algn="l">
@@ -26342,7 +25275,6 @@
           <a:lstStyle/>
           <a:p>
             <a:pPr algn="ctr"/>
-            <a:endParaRPr/>
           </a:p>
         </p:txBody>
       </p:sp>
@@ -26418,7 +25350,7 @@
       </p:sp>
       <p:pic>
         <p:nvPicPr>
-          <p:cNvPr id="5" name="Picture 4" descr="14_v4_iso_disentangle.png"/>
+          <p:cNvPr id="5" name="Picture 4" descr="image.png"/>
           <p:cNvPicPr>
             <a:picLocks noChangeAspect="1"/>
           </p:cNvPicPr>
@@ -26449,7 +25381,7 @@
         <p:spPr>
           <a:xfrm>
             <a:off x="6217920" y="1005840"/>
-            <a:ext cx="2834640" cy="4937760"/>
+            <a:ext cx="2834640" cy="4117660"/>
           </a:xfrm>
           <a:prstGeom prst="rect">
             <a:avLst/>
@@ -26696,7 +25628,7 @@
         </p:nvSpPr>
         <p:spPr>
           <a:xfrm>
-            <a:off x="457200" y="5989320"/>
+            <a:off x="457200" y="4773168"/>
             <a:ext cx="8229600" cy="320040"/>
           </a:xfrm>
           <a:prstGeom prst="rect">
@@ -26732,6 +25664,444 @@
 </file>
 
 <file path=ppt/slides/slide31.xml><?xml version="1.0" encoding="utf-8"?>
+<p:sld xmlns:a="http://schemas.openxmlformats.org/drawingml/2006/main" xmlns:p="http://schemas.openxmlformats.org/presentationml/2006/main" xmlns:r="http://schemas.openxmlformats.org/officeDocument/2006/relationships">
+  <p:cSld>
+    <p:spTree>
+      <p:nvGrpSpPr>
+        <p:cNvPr id="1" name=""/>
+        <p:cNvGrpSpPr/>
+        <p:nvPr/>
+      </p:nvGrpSpPr>
+      <p:grpSpPr/>
+      <p:sp>
+        <p:nvSpPr>
+          <p:cNvPr id="2" name="Rectangle 1"/>
+          <p:cNvSpPr/>
+          <p:nvPr/>
+        </p:nvSpPr>
+        <p:spPr>
+          <a:xfrm>
+            <a:off x="0" y="0"/>
+            <a:ext cx="9144000" cy="50292"/>
+          </a:xfrm>
+          <a:prstGeom prst="rect">
+            <a:avLst/>
+          </a:prstGeom>
+          <a:solidFill>
+            <a:srgbClr val="1A2B4B"/>
+          </a:solidFill>
+          <a:ln>
+            <a:noFill/>
+          </a:ln>
+        </p:spPr>
+        <p:style>
+          <a:lnRef idx="1">
+            <a:schemeClr val="accent1"/>
+          </a:lnRef>
+          <a:fillRef idx="3">
+            <a:schemeClr val="accent1"/>
+          </a:fillRef>
+          <a:effectRef idx="2">
+            <a:schemeClr val="accent1"/>
+          </a:effectRef>
+          <a:fontRef idx="minor">
+            <a:schemeClr val="lt1"/>
+          </a:fontRef>
+        </p:style>
+        <p:txBody>
+          <a:bodyPr rtlCol="0" anchor="ctr"/>
+          <a:lstStyle/>
+          <a:p>
+            <a:pPr algn="ctr"/>
+          </a:p>
+        </p:txBody>
+      </p:sp>
+      <p:sp>
+        <p:nvSpPr>
+          <p:cNvPr id="3" name="TextBox 2"/>
+          <p:cNvSpPr txBox="1"/>
+          <p:nvPr/>
+        </p:nvSpPr>
+        <p:spPr>
+          <a:xfrm>
+            <a:off x="457200" y="91440"/>
+            <a:ext cx="8229600" cy="201168"/>
+          </a:xfrm>
+          <a:prstGeom prst="rect">
+            <a:avLst/>
+          </a:prstGeom>
+          <a:noFill/>
+        </p:spPr>
+        <p:txBody>
+          <a:bodyPr wrap="square">
+            <a:spAutoFit/>
+          </a:bodyPr>
+          <a:lstStyle/>
+          <a:p>
+            <a:pPr algn="l">
+              <a:defRPr sz="1200" b="0">
+                <a:solidFill>
+                  <a:srgbClr val="1A2B4B"/>
+                </a:solidFill>
+              </a:defRPr>
+            </a:pPr>
+            <a:r>
+              <a:t>PART 4 · APEX-Guard</a:t>
+            </a:r>
+          </a:p>
+        </p:txBody>
+      </p:sp>
+      <p:sp>
+        <p:nvSpPr>
+          <p:cNvPr id="4" name="TextBox 3"/>
+          <p:cNvSpPr txBox="1"/>
+          <p:nvPr/>
+        </p:nvSpPr>
+        <p:spPr>
+          <a:xfrm>
+            <a:off x="457200" y="347472"/>
+            <a:ext cx="8229600" cy="594360"/>
+          </a:xfrm>
+          <a:prstGeom prst="rect">
+            <a:avLst/>
+          </a:prstGeom>
+          <a:noFill/>
+        </p:spPr>
+        <p:txBody>
+          <a:bodyPr wrap="square">
+            <a:spAutoFit/>
+          </a:bodyPr>
+          <a:lstStyle/>
+          <a:p>
+            <a:pPr algn="l">
+              <a:defRPr sz="1200" b="0">
+                <a:solidFill>
+                  <a:srgbClr val="1A2B4B"/>
+                </a:solidFill>
+              </a:defRPr>
+            </a:pPr>
+            <a:r>
+              <a:t>APEX-Guard — CA-CSS 학습 · 손실 · Isotonic</a:t>
+            </a:r>
+          </a:p>
+        </p:txBody>
+      </p:sp>
+      <p:pic>
+        <p:nvPicPr>
+          <p:cNvPr id="5" name="Picture 4" descr="image.png"/>
+          <p:cNvPicPr>
+            <a:picLocks noChangeAspect="1"/>
+          </p:cNvPicPr>
+          <p:nvPr/>
+        </p:nvPicPr>
+        <p:blipFill>
+          <a:blip r:embed="rId2"/>
+          <a:stretch>
+            <a:fillRect/>
+          </a:stretch>
+        </p:blipFill>
+        <p:spPr>
+          <a:xfrm>
+            <a:off x="228600" y="1005840"/>
+            <a:ext cx="5852160" cy="4026195"/>
+          </a:xfrm>
+          <a:prstGeom prst="rect">
+            <a:avLst/>
+          </a:prstGeom>
+        </p:spPr>
+      </p:pic>
+      <p:sp>
+        <p:nvSpPr>
+          <p:cNvPr id="6" name="TextBox 5"/>
+          <p:cNvSpPr txBox="1"/>
+          <p:nvPr/>
+        </p:nvSpPr>
+        <p:spPr>
+          <a:xfrm>
+            <a:off x="6217920" y="1005840"/>
+            <a:ext cx="2834640" cy="4117660"/>
+          </a:xfrm>
+          <a:prstGeom prst="rect">
+            <a:avLst/>
+          </a:prstGeom>
+          <a:noFill/>
+        </p:spPr>
+        <p:txBody>
+          <a:bodyPr wrap="square">
+            <a:spAutoFit/>
+          </a:bodyPr>
+          <a:lstStyle/>
+          <a:p>
+            <a:pPr>
+              <a:spcAft>
+                <a:spcPts val="400"/>
+              </a:spcAft>
+              <a:defRPr sz="950">
+                <a:solidFill>
+                  <a:srgbClr val="1A2B4B"/>
+                </a:solidFill>
+              </a:defRPr>
+            </a:pPr>
+            <a:r>
+              <a:t>【 CA-CSS 】</a:t>
+            </a:r>
+          </a:p>
+          <a:p>
+            <a:pPr>
+              <a:spcAft>
+                <a:spcPts val="400"/>
+              </a:spcAft>
+              <a:defRPr sz="950">
+                <a:solidFill>
+                  <a:srgbClr val="1A2B4B"/>
+                </a:solidFill>
+              </a:defRPr>
+            </a:pPr>
+            <a:r>
+              <a:t>Discovery-&gt;Pseudo-extrap-&gt;Compile</a:t>
+            </a:r>
+          </a:p>
+          <a:p>
+            <a:pPr>
+              <a:spcAft>
+                <a:spcPts val="400"/>
+              </a:spcAft>
+              <a:defRPr sz="950">
+                <a:solidFill>
+                  <a:srgbClr val="1A2B4B"/>
+                </a:solidFill>
+              </a:defRPr>
+            </a:pPr>
+            <a:r>
+              <a:t>train-band만 사용 (leakage 방지)</a:t>
+            </a:r>
+          </a:p>
+          <a:p>
+            <a:pPr>
+              <a:spcAft>
+                <a:spcPts val="400"/>
+              </a:spcAft>
+              <a:defRPr sz="950">
+                <a:solidFill>
+                  <a:srgbClr val="1A2B4B"/>
+                </a:solidFill>
+              </a:defRPr>
+            </a:pPr>
+            <a:r>
+              <a:t>【 손실 】</a:t>
+            </a:r>
+          </a:p>
+          <a:p>
+            <a:pPr>
+              <a:spcAft>
+                <a:spcPts val="400"/>
+              </a:spcAft>
+              <a:defRPr sz="950">
+                <a:solidFill>
+                  <a:srgbClr val="1A2B4B"/>
+                </a:solidFill>
+              </a:defRPr>
+            </a:pPr>
+            <a:r>
+              <a:t>L = L_RUL + L_physics + L_TRA</a:t>
+            </a:r>
+          </a:p>
+          <a:p>
+            <a:pPr>
+              <a:spcAft>
+                <a:spcPts val="400"/>
+              </a:spcAft>
+              <a:defRPr sz="950">
+                <a:solidFill>
+                  <a:srgbClr val="1A2B4B"/>
+                </a:solidFill>
+              </a:defRPr>
+            </a:pPr>
+            <a:r>
+              <a:t>L_physics: TRA(-) hinge</a:t>
+            </a:r>
+          </a:p>
+          <a:p>
+            <a:pPr>
+              <a:spcAft>
+                <a:spcPts val="400"/>
+              </a:spcAft>
+              <a:defRPr sz="950">
+                <a:solidFill>
+                  <a:srgbClr val="1A2B4B"/>
+                </a:solidFill>
+              </a:defRPr>
+            </a:pPr>
+            <a:r>
+              <a:t>  + cycle_mono hinge</a:t>
+            </a:r>
+          </a:p>
+          <a:p>
+            <a:pPr>
+              <a:spcAft>
+                <a:spcPts val="400"/>
+              </a:spcAft>
+              <a:defRPr sz="950">
+                <a:solidFill>
+                  <a:srgbClr val="1A2B4B"/>
+                </a:solidFill>
+              </a:defRPr>
+            </a:pPr>
+            <a:r>
+              <a:t>lambda_tra = 0.05</a:t>
+            </a:r>
+          </a:p>
+          <a:p>
+            <a:pPr>
+              <a:spcAft>
+                <a:spcPts val="400"/>
+              </a:spcAft>
+              <a:defRPr sz="950">
+                <a:solidFill>
+                  <a:srgbClr val="1A2B4B"/>
+                </a:solidFill>
+              </a:defRPr>
+            </a:pPr>
+            <a:r>
+              <a:t>【 Isotonic 】</a:t>
+            </a:r>
+          </a:p>
+          <a:p>
+            <a:pPr>
+              <a:spcAft>
+                <a:spcPts val="400"/>
+              </a:spcAft>
+              <a:defRPr sz="950">
+                <a:solidFill>
+                  <a:srgbClr val="1A2B4B"/>
+                </a:solidFill>
+              </a:defRPr>
+            </a:pPr>
+            <a:r>
+              <a:t>unit별 cycle 정렬</a:t>
+            </a:r>
+          </a:p>
+          <a:p>
+            <a:pPr>
+              <a:spcAft>
+                <a:spcPts val="400"/>
+              </a:spcAft>
+              <a:defRPr sz="950">
+                <a:solidFill>
+                  <a:srgbClr val="1A2B4B"/>
+                </a:solidFill>
+              </a:defRPr>
+            </a:pPr>
+            <a:r>
+              <a:t>decreasing isotonic post</a:t>
+            </a:r>
+          </a:p>
+          <a:p>
+            <a:pPr>
+              <a:spcAft>
+                <a:spcPts val="400"/>
+              </a:spcAft>
+              <a:defRPr sz="950">
+                <a:solidFill>
+                  <a:srgbClr val="1A2B4B"/>
+                </a:solidFill>
+              </a:defRPr>
+            </a:pPr>
+            <a:r>
+              <a:t>H1: 28% -&gt; 0%</a:t>
+            </a:r>
+          </a:p>
+          <a:p>
+            <a:pPr>
+              <a:spcAft>
+                <a:spcPts val="400"/>
+              </a:spcAft>
+              <a:defRPr sz="950">
+                <a:solidFill>
+                  <a:srgbClr val="1A2B4B"/>
+                </a:solidFill>
+              </a:defRPr>
+            </a:pPr>
+            <a:r>
+              <a:t>【 Ablation 】</a:t>
+            </a:r>
+          </a:p>
+          <a:p>
+            <a:pPr>
+              <a:spcAft>
+                <a:spcPts val="400"/>
+              </a:spcAft>
+              <a:defRPr sz="950">
+                <a:solidFill>
+                  <a:srgbClr val="1A2B4B"/>
+                </a:solidFill>
+              </a:defRPr>
+            </a:pPr>
+            <a:r>
+              <a:t>TRA+cycle adopt 핵심</a:t>
+            </a:r>
+          </a:p>
+          <a:p>
+            <a:pPr>
+              <a:spcAft>
+                <a:spcPts val="400"/>
+              </a:spcAft>
+              <a:defRPr sz="950">
+                <a:solidFill>
+                  <a:srgbClr val="1A2B4B"/>
+                </a:solidFill>
+              </a:defRPr>
+            </a:pPr>
+            <a:r>
+              <a:t>no_tra_loss: 동일 (0.05)</a:t>
+            </a:r>
+          </a:p>
+        </p:txBody>
+      </p:sp>
+      <p:sp>
+        <p:nvSpPr>
+          <p:cNvPr id="7" name="TextBox 6"/>
+          <p:cNvSpPr txBox="1"/>
+          <p:nvPr/>
+        </p:nvSpPr>
+        <p:spPr>
+          <a:xfrm>
+            <a:off x="457200" y="4773168"/>
+            <a:ext cx="8229600" cy="320040"/>
+          </a:xfrm>
+          <a:prstGeom prst="rect">
+            <a:avLst/>
+          </a:prstGeom>
+          <a:noFill/>
+        </p:spPr>
+        <p:txBody>
+          <a:bodyPr wrap="square">
+            <a:spAutoFit/>
+          </a:bodyPr>
+          <a:lstStyle/>
+          <a:p>
+            <a:pPr algn="l">
+              <a:defRPr sz="1200" b="0">
+                <a:solidFill>
+                  <a:srgbClr val="1A2B4B"/>
+                </a:solidFill>
+              </a:defRPr>
+            </a:pPr>
+            <a:r>
+              <a:t>APEX-Guard_ablation_report.md · ncmapss_unit_mono.py</a:t>
+            </a:r>
+          </a:p>
+        </p:txBody>
+      </p:sp>
+    </p:spTree>
+  </p:cSld>
+  <p:clrMapOvr>
+    <a:masterClrMapping/>
+  </p:clrMapOvr>
+</p:sld>
+</file>
+
+<file path=ppt/slides/slide32.xml><?xml version="1.0" encoding="utf-8"?>
 <p:sld xmlns:a="http://schemas.openxmlformats.org/drawingml/2006/main" xmlns:r="http://schemas.openxmlformats.org/officeDocument/2006/relationships" xmlns:p="http://schemas.openxmlformats.org/presentationml/2006/main">
   <p:cSld>
     <p:spTree>
@@ -26788,7 +26158,6 @@
           <a:lstStyle/>
           <a:p>
             <a:pPr algn="ctr"/>
-            <a:endParaRPr/>
           </a:p>
         </p:txBody>
       </p:sp>
@@ -26815,14 +26184,14 @@
           <a:lstStyle/>
           <a:p>
             <a:pPr algn="l">
-              <a:defRPr sz="1200" b="0">
-                <a:solidFill>
-                  <a:srgbClr val="1A2B4B"/>
+              <a:defRPr sz="1400" b="1">
+                <a:solidFill>
+                  <a:srgbClr val="2E86AB"/>
                 </a:solidFill>
               </a:defRPr>
             </a:pPr>
             <a:r>
-              <a:t>PART 4 · APEX-Guard</a:t>
+              <a:t>PART 4 · 실전 결과</a:t>
             </a:r>
           </a:p>
         </p:txBody>
@@ -26850,52 +26219,76 @@
           <a:lstStyle/>
           <a:p>
             <a:pPr algn="l">
-              <a:defRPr sz="1200" b="0">
+              <a:defRPr sz="2600" b="1">
                 <a:solidFill>
                   <a:srgbClr val="1A2B4B"/>
                 </a:solidFill>
               </a:defRPr>
             </a:pPr>
             <a:r>
-              <a:t>APEX-Guard — CA-CSS 학습 · 손실 · Isotonic</a:t>
+              <a:t>APEX-Guard — strict_late 검증</a:t>
             </a:r>
           </a:p>
         </p:txBody>
       </p:sp>
       <p:pic>
         <p:nvPicPr>
-          <p:cNvPr id="5" name="Picture 4" descr="15_v4_iso_train_infer.png"/>
+          <p:cNvPr id="5" name="Picture 4" descr="image.png"/>
           <p:cNvPicPr>
             <a:picLocks noChangeAspect="1"/>
           </p:cNvPicPr>
           <p:nvPr/>
         </p:nvPicPr>
         <p:blipFill>
-          <a:blip r:embed="rId2"/>
+          <a:blip r:embed="rId3"/>
           <a:stretch>
             <a:fillRect/>
           </a:stretch>
         </p:blipFill>
         <p:spPr>
           <a:xfrm>
-            <a:off x="228600" y="1005840"/>
-            <a:ext cx="5852160" cy="4026195"/>
+            <a:off x="274320" y="1051560"/>
+            <a:ext cx="4480560" cy="4071940"/>
           </a:xfrm>
           <a:prstGeom prst="rect">
             <a:avLst/>
           </a:prstGeom>
         </p:spPr>
       </p:pic>
-      <p:sp>
-        <p:nvSpPr>
-          <p:cNvPr id="6" name="TextBox 5"/>
+      <p:pic>
+        <p:nvPicPr>
+          <p:cNvPr id="6" name="Picture 5" descr="image.png"/>
+          <p:cNvPicPr>
+            <a:picLocks noChangeAspect="1"/>
+          </p:cNvPicPr>
+          <p:nvPr/>
+        </p:nvPicPr>
+        <p:blipFill>
+          <a:blip r:embed="rId4"/>
+          <a:stretch>
+            <a:fillRect/>
+          </a:stretch>
+        </p:blipFill>
+        <p:spPr>
+          <a:xfrm>
+            <a:off x="274320" y="3566160"/>
+            <a:ext cx="4480560" cy="1557340"/>
+          </a:xfrm>
+          <a:prstGeom prst="rect">
+            <a:avLst/>
+          </a:prstGeom>
+        </p:spPr>
+      </p:pic>
+      <p:sp>
+        <p:nvSpPr>
+          <p:cNvPr id="7" name="TextBox 6"/>
           <p:cNvSpPr txBox="1"/>
           <p:nvPr/>
         </p:nvSpPr>
         <p:spPr>
           <a:xfrm>
-            <a:off x="6217920" y="1005840"/>
-            <a:ext cx="2834640" cy="4937760"/>
+            <a:off x="4937760" y="1051560"/>
+            <a:ext cx="3931920" cy="4071940"/>
           </a:xfrm>
           <a:prstGeom prst="rect">
             <a:avLst/>
@@ -26908,242 +26301,92 @@
           </a:bodyPr>
           <a:lstStyle/>
           <a:p>
-            <a:pPr>
-              <a:spcAft>
-                <a:spcPts val="400"/>
-              </a:spcAft>
-              <a:defRPr sz="950">
+            <a:pPr algn="l">
+              <a:defRPr sz="1200" b="0">
                 <a:solidFill>
                   <a:srgbClr val="1A2B4B"/>
                 </a:solidFill>
               </a:defRPr>
             </a:pPr>
             <a:r>
-              <a:t>【 CA-CSS 】</a:t>
-            </a:r>
-          </a:p>
-          <a:p>
-            <a:pPr>
-              <a:spcAft>
-                <a:spcPts val="400"/>
-              </a:spcAft>
-              <a:defRPr sz="950">
-                <a:solidFill>
-                  <a:srgbClr val="1A2B4B"/>
-                </a:solidFill>
-              </a:defRPr>
-            </a:pPr>
-            <a:r>
-              <a:t>Discovery-&gt;Pseudo-extrap-&gt;Compile</a:t>
-            </a:r>
-          </a:p>
-          <a:p>
-            <a:pPr>
-              <a:spcAft>
-                <a:spcPts val="400"/>
-              </a:spcAft>
-              <a:defRPr sz="950">
-                <a:solidFill>
-                  <a:srgbClr val="1A2B4B"/>
-                </a:solidFill>
-              </a:defRPr>
-            </a:pPr>
-            <a:r>
-              <a:t>train-band만 사용 (leakage 방지)</a:t>
-            </a:r>
-          </a:p>
-          <a:p>
-            <a:pPr>
-              <a:spcAft>
-                <a:spcPts val="400"/>
-              </a:spcAft>
-              <a:defRPr sz="950">
-                <a:solidFill>
-                  <a:srgbClr val="1A2B4B"/>
-                </a:solidFill>
-              </a:defRPr>
-            </a:pPr>
-            <a:r>
-              <a:t>【 손실 】</a:t>
-            </a:r>
-          </a:p>
-          <a:p>
-            <a:pPr>
-              <a:spcAft>
-                <a:spcPts val="400"/>
-              </a:spcAft>
-              <a:defRPr sz="950">
-                <a:solidFill>
-                  <a:srgbClr val="1A2B4B"/>
-                </a:solidFill>
-              </a:defRPr>
-            </a:pPr>
-            <a:r>
-              <a:t>L = L_RUL + L_physics + L_TRA</a:t>
-            </a:r>
-          </a:p>
-          <a:p>
-            <a:pPr>
-              <a:spcAft>
-                <a:spcPts val="400"/>
-              </a:spcAft>
-              <a:defRPr sz="950">
-                <a:solidFill>
-                  <a:srgbClr val="1A2B4B"/>
-                </a:solidFill>
-              </a:defRPr>
-            </a:pPr>
-            <a:r>
-              <a:t>L_physics: TRA(-) hinge</a:t>
-            </a:r>
-          </a:p>
-          <a:p>
-            <a:pPr>
-              <a:spcAft>
-                <a:spcPts val="400"/>
-              </a:spcAft>
-              <a:defRPr sz="950">
-                <a:solidFill>
-                  <a:srgbClr val="1A2B4B"/>
-                </a:solidFill>
-              </a:defRPr>
-            </a:pPr>
-            <a:r>
-              <a:t>  + cycle_mono hinge</a:t>
-            </a:r>
-          </a:p>
-          <a:p>
-            <a:pPr>
-              <a:spcAft>
-                <a:spcPts val="400"/>
-              </a:spcAft>
-              <a:defRPr sz="950">
-                <a:solidFill>
-                  <a:srgbClr val="1A2B4B"/>
-                </a:solidFill>
-              </a:defRPr>
-            </a:pPr>
-            <a:r>
-              <a:t>lambda_tra = 0.05</a:t>
-            </a:r>
-          </a:p>
-          <a:p>
-            <a:pPr>
-              <a:spcAft>
-                <a:spcPts val="400"/>
-              </a:spcAft>
-              <a:defRPr sz="950">
-                <a:solidFill>
-                  <a:srgbClr val="1A2B4B"/>
-                </a:solidFill>
-              </a:defRPr>
-            </a:pPr>
-            <a:r>
-              <a:t>【 Isotonic 】</a:t>
-            </a:r>
-          </a:p>
-          <a:p>
-            <a:pPr>
-              <a:spcAft>
-                <a:spcPts val="400"/>
-              </a:spcAft>
-              <a:defRPr sz="950">
-                <a:solidFill>
-                  <a:srgbClr val="1A2B4B"/>
-                </a:solidFill>
-              </a:defRPr>
-            </a:pPr>
-            <a:r>
-              <a:t>unit별 cycle 정렬</a:t>
-            </a:r>
-          </a:p>
-          <a:p>
-            <a:pPr>
-              <a:spcAft>
-                <a:spcPts val="400"/>
-              </a:spcAft>
-              <a:defRPr sz="950">
-                <a:solidFill>
-                  <a:srgbClr val="1A2B4B"/>
-                </a:solidFill>
-              </a:defRPr>
-            </a:pPr>
-            <a:r>
-              <a:t>decreasing isotonic post</a:t>
-            </a:r>
-          </a:p>
-          <a:p>
-            <a:pPr>
-              <a:spcAft>
-                <a:spcPts val="400"/>
-              </a:spcAft>
-              <a:defRPr sz="950">
-                <a:solidFill>
-                  <a:srgbClr val="1A2B4B"/>
-                </a:solidFill>
-              </a:defRPr>
-            </a:pPr>
-            <a:r>
-              <a:t>H1: 28% -&gt; 0%</a:t>
-            </a:r>
-          </a:p>
-          <a:p>
-            <a:pPr>
-              <a:spcAft>
-                <a:spcPts val="400"/>
-              </a:spcAft>
-              <a:defRPr sz="950">
-                <a:solidFill>
-                  <a:srgbClr val="1A2B4B"/>
-                </a:solidFill>
-              </a:defRPr>
-            </a:pPr>
-            <a:r>
-              <a:t>【 Ablation 】</a:t>
-            </a:r>
-          </a:p>
-          <a:p>
-            <a:pPr>
-              <a:spcAft>
-                <a:spcPts val="400"/>
-              </a:spcAft>
-              <a:defRPr sz="950">
-                <a:solidFill>
-                  <a:srgbClr val="1A2B4B"/>
-                </a:solidFill>
-              </a:defRPr>
-            </a:pPr>
-            <a:r>
-              <a:t>TRA+cycle adopt 핵심</a:t>
-            </a:r>
-          </a:p>
-          <a:p>
-            <a:pPr>
-              <a:spcAft>
-                <a:spcPts val="400"/>
-              </a:spcAft>
-              <a:defRPr sz="950">
-                <a:solidFill>
-                  <a:srgbClr val="1A2B4B"/>
-                </a:solidFill>
-              </a:defRPr>
-            </a:pPr>
-            <a:r>
-              <a:t>no_tra_loss: 동일 (0.05)</a:t>
-            </a:r>
-          </a:p>
-        </p:txBody>
-      </p:sp>
-      <p:sp>
-        <p:nvSpPr>
-          <p:cNvPr id="7" name="TextBox 6"/>
+              <a:t>【 strict_late · n=201 】</a:t>
+            </a:r>
+            <a:br/>
+            <a:r>
+              <a:t>APEX-Guard   RMSE 3.26  R2 0.947</a:t>
+            </a:r>
+            <a:br/>
+            <a:r>
+              <a:t>TabPFN        RMSE 3.80  R2 0.927</a:t>
+            </a:r>
+            <a:br/>
+            <a:r>
+              <a:t>Transformer   RMSE 7.31</a:t>
+            </a:r>
+            <a:br/>
+            <a:r>
+              <a:t>TCN           RMSE 14.09</a:t>
+            </a:r>
+            <a:br/>
+            <a:br/>
+            <a:r>
+              <a:t>【 APEX-Guard 핵심 】</a:t>
+            </a:r>
+            <a:br/>
+            <a:r>
+              <a:t>Dual Enc: health(TRA=0) + load</a:t>
+            </a:r>
+            <a:br/>
+            <a:r>
+              <a:t>RUL = health - damage</a:t>
+            </a:r>
+            <a:br/>
+            <a:r>
+              <a:t>Isotonic: H1 0%</a:t>
+            </a:r>
+            <a:br/>
+            <a:br/>
+            <a:r>
+              <a:t>【 설계→성능 】</a:t>
+            </a:r>
+            <a:br/>
+            <a:r>
+              <a:t>L1: 3중 외삽 강제 평가</a:t>
+            </a:r>
+            <a:br/>
+            <a:r>
+              <a:t>L2: CA-CSS TRA(-)+cycle_mono</a:t>
+            </a:r>
+            <a:br/>
+            <a:r>
+              <a:t>L3: unit isotonic post</a:t>
+            </a:r>
+            <a:br/>
+            <a:br/>
+            <a:r>
+              <a:t>【 vs TabPFN 】</a:t>
+            </a:r>
+            <a:br/>
+            <a:r>
+              <a:t>저TRA overfit -&gt; 고TRA 급락</a:t>
+            </a:r>
+            <a:br/>
+            <a:r>
+              <a:t>APEX-Guard: 제약+단조 보완</a:t>
+            </a:r>
+          </a:p>
+        </p:txBody>
+      </p:sp>
+      <p:sp>
+        <p:nvSpPr>
+          <p:cNvPr id="8" name="TextBox 7"/>
           <p:cNvSpPr txBox="1"/>
           <p:nvPr/>
         </p:nvSpPr>
         <p:spPr>
           <a:xfrm>
-            <a:off x="457200" y="5989320"/>
-            <a:ext cx="8229600" cy="320040"/>
+            <a:off x="457200" y="4773168"/>
+            <a:ext cx="8229600" cy="256032"/>
           </a:xfrm>
           <a:prstGeom prst="rect">
             <a:avLst/>
@@ -27164,7 +26407,7 @@
               </a:defRPr>
             </a:pPr>
             <a:r>
-              <a:t>APEX-Guard_ablation_report.md · ncmapss_unit_mono.py</a:t>
+              <a:t>ca-css-ncmapss · strict_extrap_RESULTS.md · cmapss_APEX-Guard_report.md</a:t>
             </a:r>
           </a:p>
         </p:txBody>
@@ -27177,7 +26420,7 @@
 </p:sld>
 </file>
 
-<file path=ppt/slides/slide32.xml><?xml version="1.0" encoding="utf-8"?>
+<file path=ppt/slides/slide33.xml><?xml version="1.0" encoding="utf-8"?>
 <p:sld xmlns:a="http://schemas.openxmlformats.org/drawingml/2006/main" xmlns:r="http://schemas.openxmlformats.org/officeDocument/2006/relationships" xmlns:p="http://schemas.openxmlformats.org/presentationml/2006/main">
   <p:cSld name="Slide 26">
     <p:bg>
@@ -27333,7 +26576,7 @@
         <p:spPr>
           <a:xfrm>
             <a:off x="274320" y="1051560"/>
-            <a:ext cx="4480560" cy="4480560"/>
+            <a:ext cx="4480560" cy="4071940"/>
           </a:xfrm>
           <a:prstGeom prst="rect">
             <a:avLst/>
@@ -27357,7 +26600,7 @@
         <p:spPr>
           <a:xfrm>
             <a:off x="274320" y="3566160"/>
-            <a:ext cx="4480560" cy="2222500"/>
+            <a:ext cx="4480560" cy="1557340"/>
           </a:xfrm>
           <a:prstGeom prst="rect">
             <a:avLst/>
@@ -27373,7 +26616,7 @@
         <p:spPr>
           <a:xfrm>
             <a:off x="4937760" y="1051560"/>
-            <a:ext cx="3931920" cy="4846320"/>
+            <a:ext cx="3931920" cy="4071940"/>
           </a:xfrm>
           <a:prstGeom prst="rect">
             <a:avLst/>
@@ -27470,7 +26713,7 @@
         </p:nvSpPr>
         <p:spPr>
           <a:xfrm>
-            <a:off x="457200" y="5989320"/>
+            <a:off x="457200" y="4773168"/>
             <a:ext cx="8229600" cy="320040"/>
           </a:xfrm>
           <a:prstGeom prst="rect">
@@ -27505,7 +26748,7 @@
 </p:sld>
 </file>
 
-<file path=ppt/slides/slide33.xml><?xml version="1.0" encoding="utf-8"?>
+<file path=ppt/slides/slide34.xml><?xml version="1.0" encoding="utf-8"?>
 <p:sld xmlns:a="http://schemas.openxmlformats.org/drawingml/2006/main" xmlns:r="http://schemas.openxmlformats.org/officeDocument/2006/relationships" xmlns:p="http://schemas.openxmlformats.org/presentationml/2006/main">
   <p:cSld name="Slide 27">
     <p:bg>
@@ -27571,7 +26814,7 @@
         <p:spPr>
           <a:xfrm>
             <a:off x="-1097280" y="2926080"/>
-            <a:ext cx="3200400" cy="3200400"/>
+            <a:ext cx="3200400" cy="2197420"/>
           </a:xfrm>
           <a:prstGeom prst="ellipse">
             <a:avLst/>
@@ -27790,7 +27033,7 @@
 </p:sld>
 </file>
 
-<file path=ppt/slides/slide34.xml><?xml version="1.0" encoding="utf-8"?>
+<file path=ppt/slides/slide35.xml><?xml version="1.0" encoding="utf-8"?>
 <p:sld xmlns:a="http://schemas.openxmlformats.org/drawingml/2006/main" xmlns:r="http://schemas.openxmlformats.org/officeDocument/2006/relationships" xmlns:p="http://schemas.openxmlformats.org/presentationml/2006/main">
   <p:cSld name="Slide 28">
     <p:bg>
@@ -29086,7 +28329,7 @@
 </p:sld>
 </file>
 
-<file path=ppt/slides/slide35.xml><?xml version="1.0" encoding="utf-8"?>
+<file path=ppt/slides/slide36.xml><?xml version="1.0" encoding="utf-8"?>
 <p:sld xmlns:a="http://schemas.openxmlformats.org/drawingml/2006/main" xmlns:r="http://schemas.openxmlformats.org/officeDocument/2006/relationships" xmlns:p="http://schemas.openxmlformats.org/presentationml/2006/main">
   <p:cSld name="Slide 29">
     <p:bg>
@@ -30655,7 +29898,7 @@
 </p:sld>
 </file>
 
-<file path=ppt/slides/slide36.xml><?xml version="1.0" encoding="utf-8"?>
+<file path=ppt/slides/slide37.xml><?xml version="1.0" encoding="utf-8"?>
 <p:sld xmlns:a="http://schemas.openxmlformats.org/drawingml/2006/main" xmlns:r="http://schemas.openxmlformats.org/officeDocument/2006/relationships" xmlns:p="http://schemas.openxmlformats.org/presentationml/2006/main">
   <p:cSld name="Slide 30">
     <p:bg>
@@ -32033,7 +31276,7 @@
 </p:sld>
 </file>
 
-<file path=ppt/slides/slide37.xml><?xml version="1.0" encoding="utf-8"?>
+<file path=ppt/slides/slide38.xml><?xml version="1.0" encoding="utf-8"?>
 <p:sld xmlns:a="http://schemas.openxmlformats.org/drawingml/2006/main" xmlns:r="http://schemas.openxmlformats.org/officeDocument/2006/relationships" xmlns:p="http://schemas.openxmlformats.org/presentationml/2006/main">
   <p:cSld name="Slide 31">
     <p:bg>
@@ -32099,7 +31342,7 @@
         <p:spPr>
           <a:xfrm>
             <a:off x="-1097280" y="2743200"/>
-            <a:ext cx="3200400" cy="3200400"/>
+            <a:ext cx="3200400" cy="2380300"/>
           </a:xfrm>
           <a:prstGeom prst="ellipse">
             <a:avLst/>
@@ -32675,7 +31918,7 @@
 </p:sld>
 </file>
 
-<file path=ppt/slides/slide38.xml><?xml version="1.0" encoding="utf-8"?>
+<file path=ppt/slides/slide39.xml><?xml version="1.0" encoding="utf-8"?>
 <p:sld xmlns:a="http://schemas.openxmlformats.org/drawingml/2006/main" xmlns:r="http://schemas.openxmlformats.org/officeDocument/2006/relationships" xmlns:p="http://schemas.openxmlformats.org/presentationml/2006/main">
   <p:cSld name="Slide 32">
     <p:bg>
@@ -33455,7 +32698,7 @@
         <p:spPr>
           <a:xfrm>
             <a:off x="-1097280" y="2926080"/>
-            <a:ext cx="3200400" cy="3200400"/>
+            <a:ext cx="3200400" cy="2197420"/>
           </a:xfrm>
           <a:prstGeom prst="ellipse">
             <a:avLst/>
@@ -34912,7 +34155,6 @@
           <a:lstStyle/>
           <a:p>
             <a:pPr algn="ctr"/>
-            <a:endParaRPr/>
           </a:p>
         </p:txBody>
       </p:sp>
@@ -35019,7 +34261,7 @@
         <p:spPr>
           <a:xfrm>
             <a:off x="5486400" y="1097280"/>
-            <a:ext cx="3291840" cy="4572000"/>
+            <a:ext cx="3291840" cy="4026220"/>
           </a:xfrm>
           <a:prstGeom prst="rect">
             <a:avLst/>
@@ -35101,7 +34343,7 @@
         </p:nvSpPr>
         <p:spPr>
           <a:xfrm>
-            <a:off x="457200" y="5989320"/>
+            <a:off x="457200" y="4773168"/>
             <a:ext cx="8229600" cy="320040"/>
           </a:xfrm>
           <a:prstGeom prst="rect">
@@ -36051,7 +35293,6 @@
           <a:lstStyle/>
           <a:p>
             <a:pPr algn="ctr"/>
-            <a:endParaRPr/>
           </a:p>
         </p:txBody>
       </p:sp>
@@ -36158,7 +35399,7 @@
         <p:spPr>
           <a:xfrm>
             <a:off x="5486400" y="1097280"/>
-            <a:ext cx="3291840" cy="4572000"/>
+            <a:ext cx="3291840" cy="4026220"/>
           </a:xfrm>
           <a:prstGeom prst="rect">
             <a:avLst/>
@@ -36240,7 +35481,7 @@
         </p:nvSpPr>
         <p:spPr>
           <a:xfrm>
-            <a:off x="457200" y="5989320"/>
+            <a:off x="457200" y="4773168"/>
             <a:ext cx="8229600" cy="320040"/>
           </a:xfrm>
           <a:prstGeom prst="rect">
@@ -36302,218 +35543,7 @@
       </p:grpSpPr>
       <p:sp>
         <p:nvSpPr>
-          <p:cNvPr id="46" name="Text 44"/>
-          <p:cNvSpPr/>
-          <p:nvPr/>
-        </p:nvSpPr>
-        <p:spPr>
-          <a:xfrm>
-            <a:off x="457200" y="4828032"/>
-            <a:ext cx="8229600" cy="201168"/>
-          </a:xfrm>
-          <a:prstGeom prst="rect">
-            <a:avLst/>
-          </a:prstGeom>
-          <a:noFill/>
-          <a:ln/>
-        </p:spPr>
-        <p:txBody>
-          <a:bodyPr wrap="square" rtlCol="0" anchor="t"/>
-          <a:lstStyle/>
-          <a:p>
-            <a:pPr marL="0" indent="0" algn="r">
-              <a:buNone/>
-              <a:defRPr sz="1000" b="0">
-                <a:solidFill>
-                  <a:srgbClr val="666666"/>
-                </a:solidFill>
-              </a:defRPr>
-            </a:pPr>
-            <a:r>
-              <a:t>Pfister &amp; Bühlmann (2024) · Bartley et al. (2019) · Ghahramani (2013)</a:t>
-            </a:r>
-            <a:endParaRPr lang="en-US" sz="800" dirty="0"/>
-          </a:p>
-        </p:txBody>
-      </p:sp>
-      <p:sp>
-        <p:nvSpPr>
-          <p:cNvPr id="70" name="TextBox 69"/>
-          <p:cNvSpPr txBox="1"/>
-          <p:nvPr/>
-        </p:nvSpPr>
-        <p:spPr>
-          <a:xfrm>
-            <a:off x="457200" y="5989320"/>
-            <a:ext cx="8229600" cy="320040"/>
-          </a:xfrm>
-          <a:prstGeom prst="rect">
-            <a:avLst/>
-          </a:prstGeom>
-          <a:noFill/>
-        </p:spPr>
-        <p:txBody>
-          <a:bodyPr wrap="square">
-            <a:spAutoFit/>
-          </a:bodyPr>
-          <a:lstStyle/>
-          <a:p>
-            <a:pPr algn="l">
-              <a:defRPr sz="900" b="0">
-                <a:solidFill>
-                  <a:srgbClr val="555555"/>
-                </a:solidFill>
-              </a:defRPr>
-            </a:pPr>
-            <a:r>
-              <a:t>Pfister &amp; Bühlmann (2024) · Bartley et al. (2019) · Ghahramani (2013)</a:t>
-            </a:r>
-          </a:p>
-        </p:txBody>
-      </p:sp>
-      <p:sp>
-        <p:nvSpPr>
-          <p:cNvPr id="94" name="TextBox 93"/>
-          <p:cNvSpPr txBox="1"/>
-          <p:nvPr/>
-        </p:nvSpPr>
-        <p:spPr>
-          <a:xfrm>
-            <a:off x="457200" y="5989320"/>
-            <a:ext cx="8229600" cy="320040"/>
-          </a:xfrm>
-          <a:prstGeom prst="rect">
-            <a:avLst/>
-          </a:prstGeom>
-          <a:noFill/>
-        </p:spPr>
-        <p:txBody>
-          <a:bodyPr wrap="square">
-            <a:spAutoFit/>
-          </a:bodyPr>
-          <a:lstStyle/>
-          <a:p>
-            <a:pPr algn="l">
-              <a:defRPr sz="900" b="0">
-                <a:solidFill>
-                  <a:srgbClr val="555555"/>
-                </a:solidFill>
-              </a:defRPr>
-            </a:pPr>
-            <a:r>
-              <a:t>Pfister &amp; Bühlmann (2024) · Bartley et al. (2019) · Ghahramani (2013)</a:t>
-            </a:r>
-          </a:p>
-        </p:txBody>
-      </p:sp>
-      <p:sp>
-        <p:nvSpPr>
-          <p:cNvPr id="118" name="TextBox 117"/>
-          <p:cNvSpPr txBox="1"/>
-          <p:nvPr/>
-        </p:nvSpPr>
-        <p:spPr>
-          <a:xfrm>
-            <a:off x="457200" y="5989320"/>
-            <a:ext cx="8229600" cy="320040"/>
-          </a:xfrm>
-          <a:prstGeom prst="rect">
-            <a:avLst/>
-          </a:prstGeom>
-          <a:noFill/>
-        </p:spPr>
-        <p:txBody>
-          <a:bodyPr wrap="square">
-            <a:spAutoFit/>
-          </a:bodyPr>
-          <a:lstStyle/>
-          <a:p>
-            <a:pPr algn="l">
-              <a:defRPr sz="900" b="0">
-                <a:solidFill>
-                  <a:srgbClr val="555555"/>
-                </a:solidFill>
-              </a:defRPr>
-            </a:pPr>
-            <a:r>
-              <a:t>Pfister &amp; Bühlmann (2024) · Bartley et al. (2019) · Ghahramani (2013)</a:t>
-            </a:r>
-          </a:p>
-        </p:txBody>
-      </p:sp>
-      <p:sp>
-        <p:nvSpPr>
-          <p:cNvPr id="142" name="TextBox 141"/>
-          <p:cNvSpPr txBox="1"/>
-          <p:nvPr/>
-        </p:nvSpPr>
-        <p:spPr>
-          <a:xfrm>
-            <a:off x="457200" y="5989320"/>
-            <a:ext cx="8229600" cy="320040"/>
-          </a:xfrm>
-          <a:prstGeom prst="rect">
-            <a:avLst/>
-          </a:prstGeom>
-          <a:noFill/>
-        </p:spPr>
-        <p:txBody>
-          <a:bodyPr wrap="square">
-            <a:spAutoFit/>
-          </a:bodyPr>
-          <a:lstStyle/>
-          <a:p>
-            <a:pPr algn="l">
-              <a:defRPr sz="900" b="0">
-                <a:solidFill>
-                  <a:srgbClr val="555555"/>
-                </a:solidFill>
-              </a:defRPr>
-            </a:pPr>
-            <a:r>
-              <a:t>Pfister &amp; Bühlmann (2024) · Bartley et al. (2019) · Ghahramani (2013)</a:t>
-            </a:r>
-          </a:p>
-        </p:txBody>
-      </p:sp>
-      <p:sp>
-        <p:nvSpPr>
-          <p:cNvPr id="166" name="TextBox 165"/>
-          <p:cNvSpPr txBox="1"/>
-          <p:nvPr/>
-        </p:nvSpPr>
-        <p:spPr>
-          <a:xfrm>
-            <a:off x="457200" y="5989320"/>
-            <a:ext cx="8229600" cy="320040"/>
-          </a:xfrm>
-          <a:prstGeom prst="rect">
-            <a:avLst/>
-          </a:prstGeom>
-          <a:noFill/>
-        </p:spPr>
-        <p:txBody>
-          <a:bodyPr wrap="square">
-            <a:spAutoFit/>
-          </a:bodyPr>
-          <a:lstStyle/>
-          <a:p>
-            <a:pPr algn="l">
-              <a:defRPr sz="900" b="0">
-                <a:solidFill>
-                  <a:srgbClr val="555555"/>
-                </a:solidFill>
-              </a:defRPr>
-            </a:pPr>
-            <a:r>
-              <a:t>Pfister &amp; Bühlmann (2024) · Bartley et al. (2019) · Ghahramani (2013)</a:t>
-            </a:r>
-          </a:p>
-        </p:txBody>
-      </p:sp>
-      <p:sp>
-        <p:nvSpPr>
-          <p:cNvPr id="167" name="Rectangle 166"/>
+          <p:cNvPr id="2" name="Rectangle 1"/>
           <p:cNvSpPr/>
           <p:nvPr/>
         </p:nvSpPr>
@@ -36551,13 +35581,12 @@
           <a:lstStyle/>
           <a:p>
             <a:pPr algn="ctr"/>
-            <a:endParaRPr/>
-          </a:p>
-        </p:txBody>
-      </p:sp>
-      <p:sp>
-        <p:nvSpPr>
-          <p:cNvPr id="168" name="TextBox 167"/>
+          </a:p>
+        </p:txBody>
+      </p:sp>
+      <p:sp>
+        <p:nvSpPr>
+          <p:cNvPr id="3" name="TextBox 2"/>
           <p:cNvSpPr txBox="1"/>
           <p:nvPr/>
         </p:nvSpPr>
@@ -36592,7 +35621,7 @@
       </p:sp>
       <p:sp>
         <p:nvSpPr>
-          <p:cNvPr id="169" name="TextBox 168"/>
+          <p:cNvPr id="4" name="TextBox 3"/>
           <p:cNvSpPr txBox="1"/>
           <p:nvPr/>
         </p:nvSpPr>
@@ -36627,7 +35656,7 @@
       </p:sp>
       <p:sp>
         <p:nvSpPr>
-          <p:cNvPr id="170" name="Rectangle 169"/>
+          <p:cNvPr id="5" name="Rectangle 4"/>
           <p:cNvSpPr/>
           <p:nvPr/>
         </p:nvSpPr>
@@ -36661,7 +35690,7 @@
           </a:fontRef>
         </p:style>
         <p:txBody>
-          <a:bodyPr wrap="square" rtlCol="0" anchor="t"/>
+          <a:bodyPr rtlCol="0" anchor="t" wrap="square"/>
           <a:lstStyle/>
           <a:p>
             <a:pPr algn="ctr">
@@ -36672,11 +35701,6 @@
               </a:defRPr>
             </a:pPr>
             <a:r>
-              <a:rPr>
-                <a:solidFill>
-                  <a:schemeClr val="tx1"/>
-                </a:solidFill>
-              </a:rPr>
               <a:t>오차 요인</a:t>
             </a:r>
           </a:p>
@@ -36684,7 +35708,7 @@
       </p:sp>
       <p:sp>
         <p:nvSpPr>
-          <p:cNvPr id="171" name="Rectangle 170"/>
+          <p:cNvPr id="6" name="Rectangle 5"/>
           <p:cNvSpPr/>
           <p:nvPr/>
         </p:nvSpPr>
@@ -36718,7 +35742,7 @@
           </a:fontRef>
         </p:style>
         <p:txBody>
-          <a:bodyPr wrap="square" rtlCol="0" anchor="t"/>
+          <a:bodyPr rtlCol="0" anchor="t" wrap="square"/>
           <a:lstStyle/>
           <a:p>
             <a:pPr algn="ctr">
@@ -36729,11 +35753,6 @@
               </a:defRPr>
             </a:pPr>
             <a:r>
-              <a:rPr>
-                <a:solidFill>
-                  <a:schemeClr val="tx1"/>
-                </a:solidFill>
-              </a:rPr>
               <a:t>대응 불확실성</a:t>
             </a:r>
           </a:p>
@@ -36741,7 +35760,7 @@
       </p:sp>
       <p:sp>
         <p:nvSpPr>
-          <p:cNvPr id="172" name="Rectangle 171"/>
+          <p:cNvPr id="7" name="Rectangle 6"/>
           <p:cNvSpPr/>
           <p:nvPr/>
         </p:nvSpPr>
@@ -36775,7 +35794,7 @@
           </a:fontRef>
         </p:style>
         <p:txBody>
-          <a:bodyPr wrap="square" rtlCol="0" anchor="t"/>
+          <a:bodyPr rtlCol="0" anchor="t" wrap="square"/>
           <a:lstStyle/>
           <a:p>
             <a:pPr algn="ctr">
@@ -36786,11 +35805,6 @@
               </a:defRPr>
             </a:pPr>
             <a:r>
-              <a:rPr>
-                <a:solidFill>
-                  <a:schemeClr val="tx1"/>
-                </a:solidFill>
-              </a:rPr>
               <a:t>보간 영역</a:t>
             </a:r>
           </a:p>
@@ -36798,7 +35812,7 @@
       </p:sp>
       <p:sp>
         <p:nvSpPr>
-          <p:cNvPr id="173" name="Rectangle 172"/>
+          <p:cNvPr id="8" name="Rectangle 7"/>
           <p:cNvSpPr/>
           <p:nvPr/>
         </p:nvSpPr>
@@ -36832,7 +35846,7 @@
           </a:fontRef>
         </p:style>
         <p:txBody>
-          <a:bodyPr wrap="square" rtlCol="0" anchor="t"/>
+          <a:bodyPr rtlCol="0" anchor="t" wrap="square"/>
           <a:lstStyle/>
           <a:p>
             <a:pPr algn="ctr">
@@ -36843,11 +35857,6 @@
               </a:defRPr>
             </a:pPr>
             <a:r>
-              <a:rPr>
-                <a:solidFill>
-                  <a:schemeClr val="tx1"/>
-                </a:solidFill>
-              </a:rPr>
               <a:t>외삽 영역</a:t>
             </a:r>
           </a:p>
@@ -36855,7 +35864,7 @@
       </p:sp>
       <p:sp>
         <p:nvSpPr>
-          <p:cNvPr id="174" name="Rectangle 173"/>
+          <p:cNvPr id="9" name="Rectangle 8"/>
           <p:cNvSpPr/>
           <p:nvPr/>
         </p:nvSpPr>
@@ -36889,7 +35898,7 @@
           </a:fontRef>
         </p:style>
         <p:txBody>
-          <a:bodyPr wrap="square" rtlCol="0" anchor="t"/>
+          <a:bodyPr rtlCol="0" anchor="t" wrap="square"/>
           <a:lstStyle/>
           <a:p>
             <a:pPr algn="ctr">
@@ -36900,11 +35909,6 @@
               </a:defRPr>
             </a:pPr>
             <a:r>
-              <a:rPr>
-                <a:solidFill>
-                  <a:schemeClr val="tx1"/>
-                </a:solidFill>
-              </a:rPr>
               <a:t>대책</a:t>
             </a:r>
           </a:p>
@@ -36912,7 +35916,7 @@
       </p:sp>
       <p:sp>
         <p:nvSpPr>
-          <p:cNvPr id="175" name="Rectangle 174"/>
+          <p:cNvPr id="10" name="Rectangle 9"/>
           <p:cNvSpPr/>
           <p:nvPr/>
         </p:nvSpPr>
@@ -36946,7 +35950,7 @@
           </a:fontRef>
         </p:style>
         <p:txBody>
-          <a:bodyPr wrap="square" rtlCol="0" anchor="t"/>
+          <a:bodyPr rtlCol="0" anchor="t" wrap="square"/>
           <a:lstStyle/>
           <a:p>
             <a:pPr algn="ctr">
@@ -36957,11 +35961,6 @@
               </a:defRPr>
             </a:pPr>
             <a:r>
-              <a:rPr>
-                <a:solidFill>
-                  <a:schemeClr val="tx1"/>
-                </a:solidFill>
-              </a:rPr>
               <a:t>편향 (Bias)</a:t>
             </a:r>
           </a:p>
@@ -36969,7 +35968,7 @@
       </p:sp>
       <p:sp>
         <p:nvSpPr>
-          <p:cNvPr id="176" name="Rectangle 175"/>
+          <p:cNvPr id="11" name="Rectangle 10"/>
           <p:cNvSpPr/>
           <p:nvPr/>
         </p:nvSpPr>
@@ -37003,7 +36002,7 @@
           </a:fontRef>
         </p:style>
         <p:txBody>
-          <a:bodyPr wrap="square" rtlCol="0" anchor="t"/>
+          <a:bodyPr rtlCol="0" anchor="t" wrap="square"/>
           <a:lstStyle/>
           <a:p>
             <a:pPr algn="ctr">
@@ -37014,11 +36013,6 @@
               </a:defRPr>
             </a:pPr>
             <a:r>
-              <a:rPr>
-                <a:solidFill>
-                  <a:schemeClr val="tx1"/>
-                </a:solidFill>
-              </a:rPr>
               <a:t>— (UQ로 측정 불가)</a:t>
             </a:r>
           </a:p>
@@ -37026,7 +36020,7 @@
       </p:sp>
       <p:sp>
         <p:nvSpPr>
-          <p:cNvPr id="177" name="Rectangle 176"/>
+          <p:cNvPr id="12" name="Rectangle 11"/>
           <p:cNvSpPr/>
           <p:nvPr/>
         </p:nvSpPr>
@@ -37060,7 +36054,7 @@
           </a:fontRef>
         </p:style>
         <p:txBody>
-          <a:bodyPr wrap="square" rtlCol="0" anchor="t"/>
+          <a:bodyPr rtlCol="0" anchor="t" wrap="square"/>
           <a:lstStyle/>
           <a:p>
             <a:pPr algn="ctr">
@@ -37071,11 +36065,6 @@
               </a:defRPr>
             </a:pPr>
             <a:r>
-              <a:rPr>
-                <a:solidFill>
-                  <a:schemeClr val="tx1"/>
-                </a:solidFill>
-              </a:rPr>
               <a:t>모델 복잡도로 제어</a:t>
             </a:r>
           </a:p>
@@ -37083,7 +36072,7 @@
       </p:sp>
       <p:sp>
         <p:nvSpPr>
-          <p:cNvPr id="178" name="Rectangle 177"/>
+          <p:cNvPr id="13" name="Rectangle 12"/>
           <p:cNvSpPr/>
           <p:nvPr/>
         </p:nvSpPr>
@@ -37117,7 +36106,7 @@
           </a:fontRef>
         </p:style>
         <p:txBody>
-          <a:bodyPr wrap="square" rtlCol="0" anchor="t"/>
+          <a:bodyPr rtlCol="0" anchor="t" wrap="square"/>
           <a:lstStyle/>
           <a:p>
             <a:pPr algn="ctr">
@@ -37128,11 +36117,6 @@
               </a:defRPr>
             </a:pPr>
             <a:r>
-              <a:rPr>
-                <a:solidFill>
-                  <a:schemeClr val="tx1"/>
-                </a:solidFill>
-              </a:rPr>
               <a:t>가정 위반 시 오차 누적</a:t>
             </a:r>
           </a:p>
@@ -37140,7 +36124,7 @@
       </p:sp>
       <p:sp>
         <p:nvSpPr>
-          <p:cNvPr id="179" name="Rectangle 178"/>
+          <p:cNvPr id="14" name="Rectangle 13"/>
           <p:cNvSpPr/>
           <p:nvPr/>
         </p:nvSpPr>
@@ -37174,7 +36158,7 @@
           </a:fontRef>
         </p:style>
         <p:txBody>
-          <a:bodyPr wrap="square" rtlCol="0" anchor="t"/>
+          <a:bodyPr rtlCol="0" anchor="t" wrap="square"/>
           <a:lstStyle/>
           <a:p>
             <a:pPr algn="ctr">
@@ -37185,11 +36169,6 @@
               </a:defRPr>
             </a:pPr>
             <a:r>
-              <a:rPr>
-                <a:solidFill>
-                  <a:schemeClr val="tx1"/>
-                </a:solidFill>
-              </a:rPr>
               <a:t>도메인 제약·smoothness 가정</a:t>
             </a:r>
           </a:p>
@@ -37197,7 +36176,7 @@
       </p:sp>
       <p:sp>
         <p:nvSpPr>
-          <p:cNvPr id="180" name="Rectangle 179"/>
+          <p:cNvPr id="15" name="Rectangle 14"/>
           <p:cNvSpPr/>
           <p:nvPr/>
         </p:nvSpPr>
@@ -37231,7 +36210,7 @@
           </a:fontRef>
         </p:style>
         <p:txBody>
-          <a:bodyPr wrap="square" rtlCol="0" anchor="t"/>
+          <a:bodyPr rtlCol="0" anchor="t" wrap="square"/>
           <a:lstStyle/>
           <a:p>
             <a:pPr algn="ctr">
@@ -37242,11 +36221,6 @@
               </a:defRPr>
             </a:pPr>
             <a:r>
-              <a:rPr>
-                <a:solidFill>
-                  <a:schemeClr val="tx1"/>
-                </a:solidFill>
-              </a:rPr>
               <a:t>분산 (Variance)</a:t>
             </a:r>
           </a:p>
@@ -37254,7 +36228,7 @@
       </p:sp>
       <p:sp>
         <p:nvSpPr>
-          <p:cNvPr id="181" name="Rectangle 180"/>
+          <p:cNvPr id="16" name="Rectangle 15"/>
           <p:cNvSpPr/>
           <p:nvPr/>
         </p:nvSpPr>
@@ -37288,7 +36262,7 @@
           </a:fontRef>
         </p:style>
         <p:txBody>
-          <a:bodyPr wrap="square" rtlCol="0" anchor="t"/>
+          <a:bodyPr rtlCol="0" anchor="t" wrap="square"/>
           <a:lstStyle/>
           <a:p>
             <a:pPr algn="ctr">
@@ -37299,11 +36273,6 @@
               </a:defRPr>
             </a:pPr>
             <a:r>
-              <a:rPr>
-                <a:solidFill>
-                  <a:schemeClr val="tx1"/>
-                </a:solidFill>
-              </a:rPr>
               <a:t>에피스테믹 UQ</a:t>
             </a:r>
           </a:p>
@@ -37311,7 +36280,7 @@
       </p:sp>
       <p:sp>
         <p:nvSpPr>
-          <p:cNvPr id="182" name="Rectangle 181"/>
+          <p:cNvPr id="17" name="Rectangle 16"/>
           <p:cNvSpPr/>
           <p:nvPr/>
         </p:nvSpPr>
@@ -37345,7 +36314,7 @@
           </a:fontRef>
         </p:style>
         <p:txBody>
-          <a:bodyPr wrap="square" rtlCol="0" anchor="t"/>
+          <a:bodyPr rtlCol="0" anchor="t" wrap="square"/>
           <a:lstStyle/>
           <a:p>
             <a:pPr algn="ctr">
@@ -37356,11 +36325,6 @@
               </a:defRPr>
             </a:pPr>
             <a:r>
-              <a:rPr>
-                <a:solidFill>
-                  <a:schemeClr val="tx1"/>
-                </a:solidFill>
-              </a:rPr>
               <a:t>인근 데이터 많음 → 작음</a:t>
             </a:r>
           </a:p>
@@ -37368,7 +36332,7 @@
       </p:sp>
       <p:sp>
         <p:nvSpPr>
-          <p:cNvPr id="183" name="Rectangle 182"/>
+          <p:cNvPr id="18" name="Rectangle 17"/>
           <p:cNvSpPr/>
           <p:nvPr/>
         </p:nvSpPr>
@@ -37402,7 +36366,7 @@
           </a:fontRef>
         </p:style>
         <p:txBody>
-          <a:bodyPr wrap="square" rtlCol="0" anchor="t"/>
+          <a:bodyPr rtlCol="0" anchor="t" wrap="square"/>
           <a:lstStyle/>
           <a:p>
             <a:pPr algn="ctr">
@@ -37413,11 +36377,6 @@
               </a:defRPr>
             </a:pPr>
             <a:r>
-              <a:rPr>
-                <a:solidFill>
-                  <a:schemeClr val="tx1"/>
-                </a:solidFill>
-              </a:rPr>
               <a:t>인근 관측 없음 → 급증</a:t>
             </a:r>
           </a:p>
@@ -37425,7 +36384,7 @@
       </p:sp>
       <p:sp>
         <p:nvSpPr>
-          <p:cNvPr id="184" name="Rectangle 183"/>
+          <p:cNvPr id="19" name="Rectangle 18"/>
           <p:cNvSpPr/>
           <p:nvPr/>
         </p:nvSpPr>
@@ -37459,7 +36418,7 @@
           </a:fontRef>
         </p:style>
         <p:txBody>
-          <a:bodyPr wrap="square" rtlCol="0" anchor="t"/>
+          <a:bodyPr rtlCol="0" anchor="t" wrap="square"/>
           <a:lstStyle/>
           <a:p>
             <a:pPr algn="ctr">
@@ -37470,11 +36429,6 @@
               </a:defRPr>
             </a:pPr>
             <a:r>
-              <a:rPr>
-                <a:solidFill>
-                  <a:schemeClr val="tx1"/>
-                </a:solidFill>
-              </a:rPr>
               <a:t>extrapolation-aware CI</a:t>
             </a:r>
           </a:p>
@@ -37482,7 +36436,7 @@
       </p:sp>
       <p:sp>
         <p:nvSpPr>
-          <p:cNvPr id="185" name="Rectangle 184"/>
+          <p:cNvPr id="20" name="Rectangle 19"/>
           <p:cNvSpPr/>
           <p:nvPr/>
         </p:nvSpPr>
@@ -37516,7 +36470,7 @@
           </a:fontRef>
         </p:style>
         <p:txBody>
-          <a:bodyPr wrap="square" rtlCol="0" anchor="t"/>
+          <a:bodyPr rtlCol="0" anchor="t" wrap="square"/>
           <a:lstStyle/>
           <a:p>
             <a:pPr algn="ctr">
@@ -37527,11 +36481,6 @@
               </a:defRPr>
             </a:pPr>
             <a:r>
-              <a:rPr>
-                <a:solidFill>
-                  <a:schemeClr val="tx1"/>
-                </a:solidFill>
-              </a:rPr>
               <a:t>노이즈 (sigma^2)</a:t>
             </a:r>
           </a:p>
@@ -37539,7 +36488,7 @@
       </p:sp>
       <p:sp>
         <p:nvSpPr>
-          <p:cNvPr id="186" name="Rectangle 185"/>
+          <p:cNvPr id="21" name="Rectangle 20"/>
           <p:cNvSpPr/>
           <p:nvPr/>
         </p:nvSpPr>
@@ -37573,7 +36522,7 @@
           </a:fontRef>
         </p:style>
         <p:txBody>
-          <a:bodyPr wrap="square" rtlCol="0" anchor="t"/>
+          <a:bodyPr rtlCol="0" anchor="t" wrap="square"/>
           <a:lstStyle/>
           <a:p>
             <a:pPr algn="ctr">
@@ -37584,11 +36533,6 @@
               </a:defRPr>
             </a:pPr>
             <a:r>
-              <a:rPr>
-                <a:solidFill>
-                  <a:schemeClr val="tx1"/>
-                </a:solidFill>
-              </a:rPr>
               <a:t>알레아토릭 UQ</a:t>
             </a:r>
           </a:p>
@@ -37596,7 +36540,7 @@
       </p:sp>
       <p:sp>
         <p:nvSpPr>
-          <p:cNvPr id="187" name="Rectangle 186"/>
+          <p:cNvPr id="22" name="Rectangle 21"/>
           <p:cNvSpPr/>
           <p:nvPr/>
         </p:nvSpPr>
@@ -37630,7 +36574,7 @@
           </a:fontRef>
         </p:style>
         <p:txBody>
-          <a:bodyPr wrap="square" rtlCol="0" anchor="t"/>
+          <a:bodyPr rtlCol="0" anchor="t" wrap="square"/>
           <a:lstStyle/>
           <a:p>
             <a:pPr algn="ctr">
@@ -37641,11 +36585,6 @@
               </a:defRPr>
             </a:pPr>
             <a:r>
-              <a:rPr>
-                <a:solidFill>
-                  <a:schemeClr val="tx1"/>
-                </a:solidFill>
-              </a:rPr>
               <a:t>분리 측정 가능</a:t>
             </a:r>
           </a:p>
@@ -37653,7 +36592,7 @@
       </p:sp>
       <p:sp>
         <p:nvSpPr>
-          <p:cNvPr id="188" name="Rectangle 187"/>
+          <p:cNvPr id="23" name="Rectangle 22"/>
           <p:cNvSpPr/>
           <p:nvPr/>
         </p:nvSpPr>
@@ -37687,7 +36626,7 @@
           </a:fontRef>
         </p:style>
         <p:txBody>
-          <a:bodyPr wrap="square" rtlCol="0" anchor="t"/>
+          <a:bodyPr rtlCol="0" anchor="t" wrap="square"/>
           <a:lstStyle/>
           <a:p>
             <a:pPr algn="ctr">
@@ -37698,11 +36637,6 @@
               </a:defRPr>
             </a:pPr>
             <a:r>
-              <a:rPr>
-                <a:solidFill>
-                  <a:schemeClr val="tx1"/>
-                </a:solidFill>
-              </a:rPr>
               <a:t>epistemic에 묻혀 혼재</a:t>
             </a:r>
           </a:p>
@@ -37710,7 +36644,7 @@
       </p:sp>
       <p:sp>
         <p:nvSpPr>
-          <p:cNvPr id="189" name="Rectangle 188"/>
+          <p:cNvPr id="24" name="Rectangle 23"/>
           <p:cNvSpPr/>
           <p:nvPr/>
         </p:nvSpPr>
@@ -37744,7 +36678,7 @@
           </a:fontRef>
         </p:style>
         <p:txBody>
-          <a:bodyPr wrap="square" rtlCol="0" anchor="t"/>
+          <a:bodyPr rtlCol="0" anchor="t" wrap="square"/>
           <a:lstStyle/>
           <a:p>
             <a:pPr algn="ctr">
@@ -37755,55 +36689,21 @@
               </a:defRPr>
             </a:pPr>
             <a:r>
-              <a:rPr dirty="0">
-                <a:solidFill>
-                  <a:schemeClr val="tx1"/>
-                </a:solidFill>
-              </a:rPr>
-              <a:t>Bayesian UQ + </a:t>
-            </a:r>
-            <a:r>
-              <a:rPr dirty="0" err="1">
-                <a:solidFill>
-                  <a:schemeClr val="tx1"/>
-                </a:solidFill>
-              </a:rPr>
-              <a:t>반복</a:t>
-            </a:r>
-            <a:r>
-              <a:rPr dirty="0">
-                <a:solidFill>
-                  <a:schemeClr val="tx1"/>
-                </a:solidFill>
-              </a:rPr>
-              <a:t> </a:t>
-            </a:r>
-            <a:r>
-              <a:rPr dirty="0" err="1">
-                <a:solidFill>
-                  <a:schemeClr val="tx1"/>
-                </a:solidFill>
-              </a:rPr>
-              <a:t>실험</a:t>
-            </a:r>
-            <a:endParaRPr dirty="0">
-              <a:solidFill>
-                <a:schemeClr val="tx1"/>
-              </a:solidFill>
-            </a:endParaRPr>
-          </a:p>
-        </p:txBody>
-      </p:sp>
-      <p:sp>
-        <p:nvSpPr>
-          <p:cNvPr id="190" name="TextBox 189"/>
+              <a:t>Bayesian UQ + 반복 실험</a:t>
+            </a:r>
+          </a:p>
+        </p:txBody>
+      </p:sp>
+      <p:sp>
+        <p:nvSpPr>
+          <p:cNvPr id="25" name="TextBox 24"/>
           <p:cNvSpPr txBox="1"/>
           <p:nvPr/>
         </p:nvSpPr>
         <p:spPr>
           <a:xfrm>
-            <a:off x="457200" y="5989320"/>
-            <a:ext cx="8229600" cy="320040"/>
+            <a:off x="365760" y="4773168"/>
+            <a:ext cx="8412480" cy="256032"/>
           </a:xfrm>
           <a:prstGeom prst="rect">
             <a:avLst/>

</xml_diff>